<commit_message>
docs(deliverables): use current MinIO wordmark on tech stack slide
Simple Icons ships MinIO's old stork mark; replace it with the color
wordmark from MinIO's official brand assets (min.io/logo).

Checks: pptx validate.py passed; rendered in PowerPoint and inspected visually.

Co-Authored-By: Claude Opus 5.5 <noreply@anthropic.com>
</commit_message>
<xml_diff>
--- a/docs/deliverables/2_개발환경.pptx
+++ b/docs/deliverables/2_개발환경.pptx
@@ -107,7 +107,7 @@
   <p:extLst>
     <p:ext uri="{521415D9-36F7-43E2-AB2F-B90AF26B5E84}">
       <p14:sectionLst xmlns:p14="http://schemas.microsoft.com/office/powerpoint/2010/main">
-        <p14:section name="2. 개발 환경" id="{c45a4ec3-0b98-950f-250d-579af6b20ea1}">
+        <p14:section name="2. 개발 환경" id="{9935eeed-c8a5-76ef-b234-35dd87397fe3}">
           <p14:sldIdLst>
             <p14:sldId id="256"/>
           </p14:sldIdLst>
@@ -3369,8 +3369,8 @@
         </p:blipFill>
         <p:spPr>
           <a:xfrm>
-            <a:off x="2423160" y="5468112"/>
-            <a:ext cx="310896" cy="310896"/>
+            <a:off x="2423160" y="5536692"/>
+            <a:ext cx="1012811" cy="173736"/>
           </a:xfrm>
           <a:prstGeom prst="rect">
             <a:avLst/>

</xml_diff>

<commit_message>
docs(deliverables): show Coturn as a TURN badge on tech stack slide
Coturn has no official logo (not in Simple Icons; GitHub org avatar is an
identicon), so the infra row gets a neutral gray TURN text badge.

Checks: pptx validate.py passed; rendered in PowerPoint and inspected visually.

Co-Authored-By: Claude Opus 5.5 <noreply@anthropic.com>
</commit_message>
<xml_diff>
--- a/docs/deliverables/2_개발환경.pptx
+++ b/docs/deliverables/2_개발환경.pptx
@@ -107,7 +107,7 @@
   <p:extLst>
     <p:ext uri="{521415D9-36F7-43E2-AB2F-B90AF26B5E84}">
       <p14:sectionLst xmlns:p14="http://schemas.microsoft.com/office/powerpoint/2010/main">
-        <p14:section name="2. 개발 환경" id="{9935eeed-c8a5-76ef-b234-35dd87397fe3}">
+        <p14:section name="2. 개발 환경" id="{9e49313f-7f7a-396b-c80b-ba09fc56d7bb}">
           <p14:sldIdLst>
             <p14:sldId id="256"/>
           </p14:sldIdLst>
@@ -516,7 +516,7 @@
           <a:p>
             <a:r>
               <a:rPr lang="en-US" dirty="0"/>
-              <a:t>근거: 4차 프로젝트 결과 보고서 2.1, 표 4. 로고가 없는 기술(PostGIS, Pion, CameraX, OkHttp, Coturn)은 기술 열에 이름만 표기.</a:t>
+              <a:t>근거: 4차 프로젝트 결과 보고서 2.1, 표 4. 로고가 없는 기술(PostGIS, Pion, CameraX, OkHttp)은 기술 열에 이름만 표기. Coturn은 공식 로고가 없어 회색 TURN 배지로 표시.</a:t>
             </a:r>
             <a:endParaRPr lang="en-US" dirty="0"/>
           </a:p>
@@ -3425,6 +3425,46 @@
           </a:prstGeom>
         </p:spPr>
       </p:pic>
+      <p:sp>
+        <p:nvSpPr>
+          <p:cNvPr id="27" name="Badge 인프라 Coturn (공식 로고 없음)"/>
+          <p:cNvSpPr txBox="1"/>
+          <p:nvPr/>
+        </p:nvSpPr>
+        <p:spPr>
+          <a:xfrm>
+            <a:off x="3337560" y="5980176"/>
+            <a:ext cx="658368" cy="310896"/>
+          </a:xfrm>
+          <a:prstGeom prst="roundRect">
+            <a:avLst>
+              <a:gd name="adj" fmla="val 17647"/>
+            </a:avLst>
+          </a:prstGeom>
+          <a:solidFill>
+            <a:schemeClr val="tx2"/>
+          </a:solidFill>
+          <a:ln/>
+        </p:spPr>
+        <p:txBody>
+          <a:bodyPr wrap="square" lIns="0" tIns="0" rIns="0" bIns="0" rtlCol="0" anchor="ctr"/>
+          <a:lstStyle/>
+          <a:p>
+            <a:pPr algn="ctr" indent="0" marL="0">
+              <a:buNone/>
+            </a:pPr>
+            <a:r>
+              <a:rPr lang="en-US" sz="1100" b="1" spc="100" kern="0" dirty="0">
+                <a:solidFill>
+                  <a:schemeClr val="bg1"/>
+                </a:solidFill>
+              </a:rPr>
+              <a:t>TURN</a:t>
+            </a:r>
+            <a:endParaRPr lang="en-US" sz="1100" dirty="0"/>
+          </a:p>
+        </p:txBody>
+      </p:sp>
     </p:spTree>
   </p:cSld>
   <p:clrMapOvr>

</xml_diff>

<commit_message>
docs(deliverables): draw an unofficial Coturn icon for tech stack slide
Coturn has no official logo. Replace the gray TURN badge with an original
flat glyph (peer -> relay -> peer U-turn) in magenta #C8238E, a hue no other
logo on the slide uses. Source SVG added under source/assets.

Checks: pptx validate.py passed; rendered in PowerPoint and inspected visually.

Co-Authored-By: Claude Opus 5.5 <noreply@anthropic.com>
</commit_message>
<xml_diff>
--- a/docs/deliverables/2_개발환경.pptx
+++ b/docs/deliverables/2_개발환경.pptx
@@ -107,7 +107,7 @@
   <p:extLst>
     <p:ext uri="{521415D9-36F7-43E2-AB2F-B90AF26B5E84}">
       <p14:sectionLst xmlns:p14="http://schemas.microsoft.com/office/powerpoint/2010/main">
-        <p14:section name="2. 개발 환경" id="{9e49313f-7f7a-396b-c80b-ba09fc56d7bb}">
+        <p14:section name="2. 개발 환경" id="{c6b35737-f253-8974-c200-cf491dd07b07}">
           <p14:sldIdLst>
             <p14:sldId id="256"/>
           </p14:sldIdLst>
@@ -516,7 +516,7 @@
           <a:p>
             <a:r>
               <a:rPr lang="en-US" dirty="0"/>
-              <a:t>근거: 4차 프로젝트 결과 보고서 2.1, 표 4. 로고가 없는 기술(PostGIS, Pion, CameraX, OkHttp)은 기술 열에 이름만 표기. Coturn은 공식 로고가 없어 회색 TURN 배지로 표시.</a:t>
+              <a:t>근거: 4차 프로젝트 결과 보고서 2.1, 표 4. 로고가 없는 기술(PostGIS, Pion, CameraX, OkHttp)은 기술 열에 이름만 표기. Coturn은 공식 로고가 없어 이 자료용으로 새로 그린 비공식 아이콘(피어→릴레이→피어 U턴)을 사용.</a:t>
             </a:r>
             <a:endParaRPr lang="en-US" dirty="0"/>
           </a:p>
@@ -3425,46 +3425,30 @@
           </a:prstGeom>
         </p:spPr>
       </p:pic>
-      <p:sp>
-        <p:nvSpPr>
-          <p:cNvPr id="27" name="Badge 인프라 Coturn (공식 로고 없음)"/>
-          <p:cNvSpPr txBox="1"/>
+      <p:pic>
+        <p:nvPicPr>
+          <p:cNvPr id="27" name="Logo 인프라 Coturn (비공식 아이콘)" descr="Coturn (비공식 아이콘)">    </p:cNvPr>
+          <p:cNvPicPr>
+            <a:picLocks noChangeAspect="1"/>
+          </p:cNvPicPr>
           <p:nvPr/>
-        </p:nvSpPr>
+        </p:nvPicPr>
+        <p:blipFill>
+          <a:blip r:embed="rId23"/>
+          <a:stretch>
+            <a:fillRect/>
+          </a:stretch>
+        </p:blipFill>
         <p:spPr>
           <a:xfrm>
             <a:off x="3337560" y="5980176"/>
-            <a:ext cx="658368" cy="310896"/>
+            <a:ext cx="310896" cy="310896"/>
           </a:xfrm>
-          <a:prstGeom prst="roundRect">
-            <a:avLst>
-              <a:gd name="adj" fmla="val 17647"/>
-            </a:avLst>
+          <a:prstGeom prst="rect">
+            <a:avLst/>
           </a:prstGeom>
-          <a:solidFill>
-            <a:schemeClr val="tx2"/>
-          </a:solidFill>
-          <a:ln/>
         </p:spPr>
-        <p:txBody>
-          <a:bodyPr wrap="square" lIns="0" tIns="0" rIns="0" bIns="0" rtlCol="0" anchor="ctr"/>
-          <a:lstStyle/>
-          <a:p>
-            <a:pPr algn="ctr" indent="0" marL="0">
-              <a:buNone/>
-            </a:pPr>
-            <a:r>
-              <a:rPr lang="en-US" sz="1100" b="1" spc="100" kern="0" dirty="0">
-                <a:solidFill>
-                  <a:schemeClr val="bg1"/>
-                </a:solidFill>
-              </a:rPr>
-              <a:t>TURN</a:t>
-            </a:r>
-            <a:endParaRPr lang="en-US" sz="1100" dirty="0"/>
-          </a:p>
-        </p:txBody>
-      </p:sp>
+      </p:pic>
     </p:spTree>
   </p:cSld>
   <p:clrMapOvr>

</xml_diff>

<commit_message>
docs(deliverables): add TensorRT with NVIDIA logo to vision row
The Vision service runs the TensorRT engine a4_best.engine (report 2.5), which
표 4 omits. Add TensorRT to the vision row's tech text with NVIDIA's logo
(TensorRT has no separate mark) and widen the tech column so it stays on one line.

Checks: pptx validate.py passed; rendered in PowerPoint and inspected visually.

Co-Authored-By: Claude Opus 5.5 <noreply@anthropic.com>
</commit_message>
<xml_diff>
--- a/docs/deliverables/2_개발환경.pptx
+++ b/docs/deliverables/2_개발환경.pptx
@@ -107,7 +107,7 @@
   <p:extLst>
     <p:ext uri="{521415D9-36F7-43E2-AB2F-B90AF26B5E84}">
       <p14:sectionLst xmlns:p14="http://schemas.microsoft.com/office/powerpoint/2010/main">
-        <p14:section name="2. 개발 환경" id="{c6b35737-f253-8974-c200-cf491dd07b07}">
+        <p14:section name="2. 개발 환경" id="{613efcde-4066-fc20-2703-41f99221b3ff}">
           <p14:sldIdLst>
             <p14:sldId id="256"/>
           </p14:sldIdLst>
@@ -516,7 +516,7 @@
           <a:p>
             <a:r>
               <a:rPr lang="en-US" dirty="0"/>
-              <a:t>근거: 4차 프로젝트 결과 보고서 2.1, 표 4. 로고가 없는 기술(PostGIS, Pion, CameraX, OkHttp)은 기술 열에 이름만 표기. Coturn은 공식 로고가 없어 이 자료용으로 새로 그린 비공식 아이콘(피어→릴레이→피어 U턴)을 사용.</a:t>
+              <a:t>근거: 4차 프로젝트 결과 보고서 2.1, 표 4. 로고가 없는 기술(PostGIS, Pion, CameraX, OkHttp)은 기술 열에 이름만 표기. Coturn은 공식 로고가 없어 이 자료용으로 새로 그린 비공식 아이콘(피어→릴레이→피어 U턴)을 사용. 비전 행의 TensorRT(NVIDIA)는 보고서 표 4에는 없고 2.5의 a4_best.engine 기준으로 추가.</a:t>
             </a:r>
             <a:endParaRPr lang="en-US" dirty="0"/>
           </a:p>
@@ -1053,8 +1053,8 @@
               <a:tblGrid>
                 <a:gridCol w="1737360"/>
                 <a:gridCol w="2103120"/>
-                <a:gridCol w="3566160"/>
-                <a:gridCol w="3685032"/>
+                <a:gridCol w="4114800"/>
+                <a:gridCol w="3136392"/>
               </a:tblGrid>
               <a:tr h="411480">
                 <a:tc>
@@ -2099,7 +2099,7 @@
                           <a:ea typeface="Malgun Gothic" pitchFamily="34" charset="-122"/>
                           <a:cs typeface="Malgun Gothic" pitchFamily="34" charset="-120"/>
                         </a:rPr>
-                        <a:t>Python 3.12, PyTorch, Ultralytics</a:t>
+                        <a:t>Python 3.12, PyTorch, Ultralytics, TensorRT</a:t>
                       </a:r>
                       <a:endParaRPr lang="en-US" sz="1400" dirty="0">
                         <a:latin typeface="Malgun Gothic" charset="0"/>
@@ -3259,7 +3259,7 @@
       </p:pic>
       <p:pic>
         <p:nvPicPr>
-          <p:cNvPr id="20" name="Logo 차량 단말 Kotlin" descr="Kotlin">    </p:cNvPr>
+          <p:cNvPr id="20" name="Logo 비전 NVIDIA" descr="NVIDIA">    </p:cNvPr>
           <p:cNvPicPr>
             <a:picLocks noChangeAspect="1"/>
           </p:cNvPicPr>
@@ -3267,6 +3267,30 @@
         </p:nvPicPr>
         <p:blipFill>
           <a:blip r:embed="rId16"/>
+          <a:stretch>
+            <a:fillRect/>
+          </a:stretch>
+        </p:blipFill>
+        <p:spPr>
+          <a:xfrm>
+            <a:off x="3794760" y="3931920"/>
+            <a:ext cx="310896" cy="310896"/>
+          </a:xfrm>
+          <a:prstGeom prst="rect">
+            <a:avLst/>
+          </a:prstGeom>
+        </p:spPr>
+      </p:pic>
+      <p:pic>
+        <p:nvPicPr>
+          <p:cNvPr id="21" name="Logo 차량 단말 Kotlin" descr="Kotlin">    </p:cNvPr>
+          <p:cNvPicPr>
+            <a:picLocks noChangeAspect="1"/>
+          </p:cNvPicPr>
+          <p:nvPr/>
+        </p:nvPicPr>
+        <p:blipFill>
+          <a:blip r:embed="rId17"/>
           <a:stretch>
             <a:fillRect/>
           </a:stretch>
@@ -3283,14 +3307,14 @@
       </p:pic>
       <p:pic>
         <p:nvPicPr>
-          <p:cNvPr id="21" name="Logo 차량 단말 Android" descr="Android">    </p:cNvPr>
+          <p:cNvPr id="22" name="Logo 차량 단말 Android" descr="Android">    </p:cNvPr>
           <p:cNvPicPr>
             <a:picLocks noChangeAspect="1"/>
           </p:cNvPicPr>
           <p:nvPr/>
         </p:nvPicPr>
         <p:blipFill>
-          <a:blip r:embed="rId17"/>
+          <a:blip r:embed="rId18"/>
           <a:stretch>
             <a:fillRect/>
           </a:stretch>
@@ -3307,14 +3331,14 @@
       </p:pic>
       <p:pic>
         <p:nvPicPr>
-          <p:cNvPr id="22" name="Logo 차량 단말 WebRTC" descr="WebRTC">    </p:cNvPr>
+          <p:cNvPr id="23" name="Logo 차량 단말 WebRTC" descr="WebRTC">    </p:cNvPr>
           <p:cNvPicPr>
             <a:picLocks noChangeAspect="1"/>
           </p:cNvPicPr>
           <p:nvPr/>
         </p:nvPicPr>
         <p:blipFill>
-          <a:blip r:embed="rId18"/>
+          <a:blip r:embed="rId19"/>
           <a:stretch>
             <a:fillRect/>
           </a:stretch>
@@ -3331,14 +3355,14 @@
       </p:pic>
       <p:pic>
         <p:nvPicPr>
-          <p:cNvPr id="23" name="Logo 업무 저장소 PostgreSQL" descr="PostgreSQL">    </p:cNvPr>
+          <p:cNvPr id="24" name="Logo 업무 저장소 PostgreSQL" descr="PostgreSQL">    </p:cNvPr>
           <p:cNvPicPr>
             <a:picLocks noChangeAspect="1"/>
           </p:cNvPicPr>
           <p:nvPr/>
         </p:nvPicPr>
         <p:blipFill>
-          <a:blip r:embed="rId19"/>
+          <a:blip r:embed="rId20"/>
           <a:stretch>
             <a:fillRect/>
           </a:stretch>
@@ -3355,14 +3379,14 @@
       </p:pic>
       <p:pic>
         <p:nvPicPr>
-          <p:cNvPr id="24" name="Logo 객체 저장소 MinIO" descr="MinIO">    </p:cNvPr>
+          <p:cNvPr id="25" name="Logo 객체 저장소 MinIO" descr="MinIO">    </p:cNvPr>
           <p:cNvPicPr>
             <a:picLocks noChangeAspect="1"/>
           </p:cNvPicPr>
           <p:nvPr/>
         </p:nvPicPr>
         <p:blipFill>
-          <a:blip r:embed="rId20"/>
+          <a:blip r:embed="rId21"/>
           <a:stretch>
             <a:fillRect/>
           </a:stretch>
@@ -3379,14 +3403,14 @@
       </p:pic>
       <p:pic>
         <p:nvPicPr>
-          <p:cNvPr id="25" name="Logo 인프라 Docker" descr="Docker">    </p:cNvPr>
+          <p:cNvPr id="26" name="Logo 인프라 Docker" descr="Docker">    </p:cNvPr>
           <p:cNvPicPr>
             <a:picLocks noChangeAspect="1"/>
           </p:cNvPicPr>
           <p:nvPr/>
         </p:nvPicPr>
         <p:blipFill>
-          <a:blip r:embed="rId21"/>
+          <a:blip r:embed="rId22"/>
           <a:stretch>
             <a:fillRect/>
           </a:stretch>
@@ -3403,14 +3427,14 @@
       </p:pic>
       <p:pic>
         <p:nvPicPr>
-          <p:cNvPr id="26" name="Logo 인프라 NGINX" descr="NGINX">    </p:cNvPr>
+          <p:cNvPr id="27" name="Logo 인프라 NGINX" descr="NGINX">    </p:cNvPr>
           <p:cNvPicPr>
             <a:picLocks noChangeAspect="1"/>
           </p:cNvPicPr>
           <p:nvPr/>
         </p:nvPicPr>
         <p:blipFill>
-          <a:blip r:embed="rId22"/>
+          <a:blip r:embed="rId23"/>
           <a:stretch>
             <a:fillRect/>
           </a:stretch>
@@ -3427,14 +3451,14 @@
       </p:pic>
       <p:pic>
         <p:nvPicPr>
-          <p:cNvPr id="27" name="Logo 인프라 Coturn (비공식 아이콘)" descr="Coturn (비공식 아이콘)">    </p:cNvPr>
+          <p:cNvPr id="28" name="Logo 인프라 Coturn (비공식 아이콘)" descr="Coturn (비공식 아이콘)">    </p:cNvPr>
           <p:cNvPicPr>
             <a:picLocks noChangeAspect="1"/>
           </p:cNvPicPr>
           <p:nvPr/>
         </p:nvPicPr>
         <p:blipFill>
-          <a:blip r:embed="rId23"/>
+          <a:blip r:embed="rId24"/>
           <a:stretch>
             <a:fillRect/>
           </a:stretch>

</xml_diff>

<commit_message>
feat(doc): change minio icon size
</commit_message>
<xml_diff>
--- a/docs/deliverables/2_개발환경.pptx
+++ b/docs/deliverables/2_개발환경.pptx
@@ -4,12 +4,12 @@
   <p:sldMasterIdLst>
     <p:sldMasterId id="2147483648" r:id="rId1"/>
   </p:sldMasterIdLst>
+  <p:notesMasterIdLst>
+    <p:notesMasterId r:id="rId3"/>
+  </p:notesMasterIdLst>
   <p:sldIdLst>
     <p:sldId id="256" r:id="rId2"/>
   </p:sldIdLst>
-  <p:notesMasterIdLst>
-    <p:notesMasterId r:id="rId3"/>
-  </p:notesMasterIdLst>
   <p:sldSz cx="12192000" cy="6858000"/>
   <p:notesSz cx="6858000" cy="12192000"/>
   <p:defaultTextStyle>
@@ -107,7 +107,7 @@
   <p:extLst>
     <p:ext uri="{521415D9-36F7-43E2-AB2F-B90AF26B5E84}">
       <p14:sectionLst xmlns:p14="http://schemas.microsoft.com/office/powerpoint/2010/main">
-        <p14:section name="2. 개발 환경" id="{613efcde-4066-fc20-2703-41f99221b3ff}">
+        <p14:section name="2. 개발 환경" id="{613EFCDE-4066-FC20-2703-41F99221B3FF}">
           <p14:sldIdLst>
             <p14:sldId id="256"/>
           </p14:sldIdLst>
@@ -143,240 +143,16 @@
           <a:chExt cx="0" cy="0"/>
         </a:xfrm>
       </p:grpSpPr>
-      <p:sp>
-        <p:nvSpPr>
-          <p:cNvPr id="2" name="Header Placeholder 1"/>
-          <p:cNvSpPr>
-            <a:spLocks noGrp="1"/>
-          </p:cNvSpPr>
-          <p:nvPr>
-            <p:ph type="hdr" sz="quarter"/>
-          </p:nvPr>
-        </p:nvSpPr>
-        <p:spPr>
-          <a:xfrm>
-            <a:off x="0" y="0"/>
-            <a:ext cx="2971800" cy="458788"/>
-          </a:xfrm>
-          <a:prstGeom prst="rect">
-            <a:avLst/>
-          </a:prstGeom>
-        </p:spPr>
-        <p:txBody>
-          <a:bodyPr vert="horz" lIns="91440" tIns="45720" rIns="91440" bIns="45720" rtlCol="0"/>
-          <a:lstStyle>
-            <a:lvl1pPr algn="l">
-              <a:defRPr sz="1200"/>
-            </a:lvl1pPr>
-          </a:lstStyle>
-          <a:p>
-            <a:endParaRPr lang="en-US"/>
-          </a:p>
-        </p:txBody>
-      </p:sp>
-      <p:sp>
-        <p:nvSpPr>
-          <p:cNvPr id="3" name="Date Placeholder 2"/>
-          <p:cNvSpPr>
-            <a:spLocks noGrp="1"/>
-          </p:cNvSpPr>
-          <p:nvPr>
-            <p:ph type="dt" idx="1"/>
-          </p:nvPr>
-        </p:nvSpPr>
-        <p:spPr>
-          <a:xfrm>
-            <a:off x="3884613" y="0"/>
-            <a:ext cx="2971800" cy="458788"/>
-          </a:xfrm>
-          <a:prstGeom prst="rect">
-            <a:avLst/>
-          </a:prstGeom>
-        </p:spPr>
-        <p:txBody>
-          <a:bodyPr vert="horz" lIns="91440" tIns="45720" rIns="91440" bIns="45720" rtlCol="0"/>
-          <a:lstStyle>
-            <a:lvl1pPr algn="r">
-              <a:defRPr sz="1200"/>
-            </a:lvl1pPr>
-          </a:lstStyle>
-          <a:p>
-            <a:fld id="{5282F153-3F37-0F45-9E97-73ACFA13230C}" type="datetimeFigureOut">
-              <a:rPr lang="en-US"/>
-              <a:t>7/23/19</a:t>
-            </a:fld>
-            <a:endParaRPr lang="en-US"/>
-          </a:p>
-        </p:txBody>
-      </p:sp>
-      <p:sp>
-        <p:nvSpPr>
-          <p:cNvPr id="4" name="Slide Image Placeholder 3"/>
-          <p:cNvSpPr>
-            <a:spLocks noGrp="1" noRot="1" noChangeAspect="1"/>
-          </p:cNvSpPr>
-          <p:nvPr>
-            <p:ph type="sldImg" idx="2"/>
-          </p:nvPr>
-        </p:nvSpPr>
-        <p:spPr>
-          <a:xfrm>
-            <a:off x="685800" y="1143000"/>
-            <a:ext cx="5486400" cy="3086100"/>
-          </a:xfrm>
-          <a:prstGeom prst="rect">
-            <a:avLst/>
-          </a:prstGeom>
-          <a:noFill/>
-          <a:ln w="12700">
-            <a:solidFill>
-              <a:prstClr val="black"/>
-            </a:solidFill>
-          </a:ln>
-        </p:spPr>
-        <p:txBody>
-          <a:bodyPr vert="horz" lIns="91440" tIns="45720" rIns="91440" bIns="45720" rtlCol="0" anchor="ctr"/>
-          <a:lstStyle/>
-          <a:p>
-            <a:endParaRPr lang="en-US"/>
-          </a:p>
-        </p:txBody>
-      </p:sp>
-      <p:sp>
-        <p:nvSpPr>
-          <p:cNvPr id="5" name="Notes Placeholder 4"/>
-          <p:cNvSpPr>
-            <a:spLocks noGrp="1"/>
-          </p:cNvSpPr>
-          <p:nvPr>
-            <p:ph type="body" sz="quarter" idx="3"/>
-          </p:nvPr>
-        </p:nvSpPr>
-        <p:spPr>
-          <a:xfrm>
-            <a:off x="685800" y="4400550"/>
-            <a:ext cx="5486400" cy="3600450"/>
-          </a:xfrm>
-          <a:prstGeom prst="rect">
-            <a:avLst/>
-          </a:prstGeom>
-        </p:spPr>
-        <p:txBody>
-          <a:bodyPr vert="horz" lIns="91440" tIns="45720" rIns="91440" bIns="45720" rtlCol="0"/>
-          <a:lstStyle/>
-          <a:p>
-            <a:pPr lvl="0"/>
-            <a:r>
-              <a:rPr lang="en-US"/>
-              <a:t>Click to edit Master text styles</a:t>
-            </a:r>
-          </a:p>
-          <a:p>
-            <a:pPr lvl="1"/>
-            <a:r>
-              <a:rPr lang="en-US"/>
-              <a:t>Second level</a:t>
-            </a:r>
-          </a:p>
-          <a:p>
-            <a:pPr lvl="2"/>
-            <a:r>
-              <a:rPr lang="en-US"/>
-              <a:t>Third level</a:t>
-            </a:r>
-          </a:p>
-          <a:p>
-            <a:pPr lvl="3"/>
-            <a:r>
-              <a:rPr lang="en-US"/>
-              <a:t>Fourth level</a:t>
-            </a:r>
-          </a:p>
-          <a:p>
-            <a:pPr lvl="4"/>
-            <a:r>
-              <a:rPr lang="en-US"/>
-              <a:t>Fifth level</a:t>
-            </a:r>
-          </a:p>
-        </p:txBody>
-      </p:sp>
-      <p:sp>
-        <p:nvSpPr>
-          <p:cNvPr id="6" name="Footer Placeholder 5"/>
-          <p:cNvSpPr>
-            <a:spLocks noGrp="1"/>
-          </p:cNvSpPr>
-          <p:nvPr>
-            <p:ph type="ftr" sz="quarter" idx="4"/>
-          </p:nvPr>
-        </p:nvSpPr>
-        <p:spPr>
-          <a:xfrm>
-            <a:off x="0" y="8685213"/>
-            <a:ext cx="2971800" cy="458787"/>
-          </a:xfrm>
-          <a:prstGeom prst="rect">
-            <a:avLst/>
-          </a:prstGeom>
-        </p:spPr>
-        <p:txBody>
-          <a:bodyPr vert="horz" lIns="91440" tIns="45720" rIns="91440" bIns="45720" rtlCol="0" anchor="b"/>
-          <a:lstStyle>
-            <a:lvl1pPr algn="l">
-              <a:defRPr sz="1200"/>
-            </a:lvl1pPr>
-          </a:lstStyle>
-          <a:p>
-            <a:endParaRPr lang="en-US"/>
-          </a:p>
-        </p:txBody>
-      </p:sp>
-      <p:sp>
-        <p:nvSpPr>
-          <p:cNvPr id="7" name="Slide Number Placeholder 6"/>
-          <p:cNvSpPr>
-            <a:spLocks noGrp="1"/>
-          </p:cNvSpPr>
-          <p:nvPr>
-            <p:ph type="sldNum" sz="quarter" idx="5"/>
-          </p:nvPr>
-        </p:nvSpPr>
-        <p:spPr>
-          <a:xfrm>
-            <a:off x="3884613" y="8685213"/>
-            <a:ext cx="2971800" cy="458787"/>
-          </a:xfrm>
-          <a:prstGeom prst="rect">
-            <a:avLst/>
-          </a:prstGeom>
-        </p:spPr>
-        <p:txBody>
-          <a:bodyPr vert="horz" lIns="91440" tIns="45720" rIns="91440" bIns="45720" rtlCol="0" anchor="b"/>
-          <a:lstStyle>
-            <a:lvl1pPr algn="r">
-              <a:defRPr sz="1200"/>
-            </a:lvl1pPr>
-          </a:lstStyle>
-          <a:p>
-            <a:fld id="{CE5E9CC1-C706-0F49-92D6-E571CC5EEA8F}" type="slidenum">
-              <a:rPr lang="en-US"/>
-              <a:t>‹#›</a:t>
-            </a:fld>
-            <a:endParaRPr lang="en-US"/>
-          </a:p>
-        </p:txBody>
-      </p:sp>
     </p:spTree>
     <p:extLst>
       <p:ext uri="{BB962C8B-B14F-4D97-AF65-F5344CB8AC3E}">
-        <p14:creationId xmlns:p14="http://schemas.microsoft.com/office/powerpoint/2010/main" val="1024086991"/>
+        <p14:creationId xmlns:p14="http://schemas.microsoft.com/office/powerpoint/2010/main" val="356802063"/>
       </p:ext>
     </p:extLst>
   </p:cSld>
   <p:clrMap bg1="lt1" tx1="dk1" bg2="lt2" tx2="dk2" accent1="accent1" accent2="accent2" accent3="accent3" accent4="accent4" accent5="accent5" accent6="accent6" hlink="hlink" folHlink="folHlink"/>
   <p:notesStyle>
-    <a:lvl1pPr marL="0" algn="l" defTabSz="914400" rtl="0" eaLnBrk="1" latinLnBrk="0" hangingPunct="1">
+    <a:lvl1pPr marL="0" algn="l" defTabSz="914400" rtl="0" eaLnBrk="1" latinLnBrk="1" hangingPunct="1">
       <a:defRPr sz="1200" kern="1200">
         <a:solidFill>
           <a:schemeClr val="tx1"/>
@@ -386,7 +162,7 @@
         <a:cs typeface="+mn-cs"/>
       </a:defRPr>
     </a:lvl1pPr>
-    <a:lvl2pPr marL="457200" algn="l" defTabSz="914400" rtl="0" eaLnBrk="1" latinLnBrk="0" hangingPunct="1">
+    <a:lvl2pPr marL="457200" algn="l" defTabSz="914400" rtl="0" eaLnBrk="1" latinLnBrk="1" hangingPunct="1">
       <a:defRPr sz="1200" kern="1200">
         <a:solidFill>
           <a:schemeClr val="tx1"/>
@@ -396,7 +172,7 @@
         <a:cs typeface="+mn-cs"/>
       </a:defRPr>
     </a:lvl2pPr>
-    <a:lvl3pPr marL="914400" algn="l" defTabSz="914400" rtl="0" eaLnBrk="1" latinLnBrk="0" hangingPunct="1">
+    <a:lvl3pPr marL="914400" algn="l" defTabSz="914400" rtl="0" eaLnBrk="1" latinLnBrk="1" hangingPunct="1">
       <a:defRPr sz="1200" kern="1200">
         <a:solidFill>
           <a:schemeClr val="tx1"/>
@@ -406,7 +182,7 @@
         <a:cs typeface="+mn-cs"/>
       </a:defRPr>
     </a:lvl3pPr>
-    <a:lvl4pPr marL="1371600" algn="l" defTabSz="914400" rtl="0" eaLnBrk="1" latinLnBrk="0" hangingPunct="1">
+    <a:lvl4pPr marL="1371600" algn="l" defTabSz="914400" rtl="0" eaLnBrk="1" latinLnBrk="1" hangingPunct="1">
       <a:defRPr sz="1200" kern="1200">
         <a:solidFill>
           <a:schemeClr val="tx1"/>
@@ -416,7 +192,7 @@
         <a:cs typeface="+mn-cs"/>
       </a:defRPr>
     </a:lvl4pPr>
-    <a:lvl5pPr marL="1828800" algn="l" defTabSz="914400" rtl="0" eaLnBrk="1" latinLnBrk="0" hangingPunct="1">
+    <a:lvl5pPr marL="1828800" algn="l" defTabSz="914400" rtl="0" eaLnBrk="1" latinLnBrk="1" hangingPunct="1">
       <a:defRPr sz="1200" kern="1200">
         <a:solidFill>
           <a:schemeClr val="tx1"/>
@@ -426,7 +202,7 @@
         <a:cs typeface="+mn-cs"/>
       </a:defRPr>
     </a:lvl5pPr>
-    <a:lvl6pPr marL="2286000" algn="l" defTabSz="914400" rtl="0" eaLnBrk="1" latinLnBrk="0" hangingPunct="1">
+    <a:lvl6pPr marL="2286000" algn="l" defTabSz="914400" rtl="0" eaLnBrk="1" latinLnBrk="1" hangingPunct="1">
       <a:defRPr sz="1200" kern="1200">
         <a:solidFill>
           <a:schemeClr val="tx1"/>
@@ -436,7 +212,7 @@
         <a:cs typeface="+mn-cs"/>
       </a:defRPr>
     </a:lvl6pPr>
-    <a:lvl7pPr marL="2743200" algn="l" defTabSz="914400" rtl="0" eaLnBrk="1" latinLnBrk="0" hangingPunct="1">
+    <a:lvl7pPr marL="2743200" algn="l" defTabSz="914400" rtl="0" eaLnBrk="1" latinLnBrk="1" hangingPunct="1">
       <a:defRPr sz="1200" kern="1200">
         <a:solidFill>
           <a:schemeClr val="tx1"/>
@@ -446,7 +222,7 @@
         <a:cs typeface="+mn-cs"/>
       </a:defRPr>
     </a:lvl7pPr>
-    <a:lvl8pPr marL="3200400" algn="l" defTabSz="914400" rtl="0" eaLnBrk="1" latinLnBrk="0" hangingPunct="1">
+    <a:lvl8pPr marL="3200400" algn="l" defTabSz="914400" rtl="0" eaLnBrk="1" latinLnBrk="1" hangingPunct="1">
       <a:defRPr sz="1200" kern="1200">
         <a:solidFill>
           <a:schemeClr val="tx1"/>
@@ -456,7 +232,7 @@
         <a:cs typeface="+mn-cs"/>
       </a:defRPr>
     </a:lvl8pPr>
-    <a:lvl9pPr marL="3657600" algn="l" defTabSz="914400" rtl="0" eaLnBrk="1" latinLnBrk="0" hangingPunct="1">
+    <a:lvl9pPr marL="3657600" algn="l" defTabSz="914400" rtl="0" eaLnBrk="1" latinLnBrk="1" hangingPunct="1">
       <a:defRPr sz="1200" kern="1200">
         <a:solidFill>
           <a:schemeClr val="tx1"/>
@@ -518,7 +294,6 @@
               <a:rPr lang="en-US" dirty="0"/>
               <a:t>근거: 4차 프로젝트 결과 보고서 2.1, 표 4. 로고가 없는 기술(PostGIS, Pion, CameraX, OkHttp)은 기술 열에 이름만 표기. Coturn은 공식 로고가 없어 이 자료용으로 새로 그린 비공식 아이콘(피어→릴레이→피어 U턴)을 사용. 비전 행의 TensorRT(NVIDIA)는 보고서 표 4에는 없고 2.5의 a4_best.engine 기준으로 추가.</a:t>
             </a:r>
-            <a:endParaRPr lang="en-US" dirty="0"/>
           </a:p>
         </p:txBody>
       </p:sp>
@@ -596,6 +371,7 @@
         <a:solidFill>
           <a:schemeClr val="bg1"/>
         </a:solidFill>
+        <a:effectLst/>
       </p:bgPr>
     </p:bg>
     <p:spTree>
@@ -615,9 +391,11 @@
       <p:sp>
         <p:nvSpPr>
           <p:cNvPr id="2" name="Text 0"/>
-          <p:cNvSpPr/>
+          <p:cNvSpPr>
+            <a:spLocks noGrp="1"/>
+          </p:cNvSpPr>
           <p:nvPr>
-            <p:ph idx="100" type="title" hasCustomPrompt="1"/>
+            <p:ph type="title" idx="100" hasCustomPrompt="1"/>
           </p:nvPr>
         </p:nvSpPr>
         <p:spPr>
@@ -634,7 +412,7 @@
         <p:txBody>
           <a:bodyPr wrap="square" rtlCol="0"/>
           <a:lstStyle>
-            <a:lvl1pPr algn="l" indent="0" marL="0">
+            <a:lvl1pPr marL="0" indent="0" algn="l">
               <a:buNone/>
               <a:defRPr lang="en-US" sz="3200" b="1" dirty="0">
                 <a:solidFill>
@@ -644,7 +422,7 @@
             </a:lvl1pPr>
           </a:lstStyle>
           <a:p>
-            <a:pPr algn="l" indent="0" marL="0">
+            <a:pPr marL="0" indent="0" algn="l">
               <a:buNone/>
             </a:pPr>
             <a:endParaRPr lang="en-US" sz="3200" dirty="0"/>
@@ -662,6 +440,11 @@
 <file path=ppt/slideMasters/slideMaster1.xml><?xml version="1.0" encoding="utf-8"?>
 <p:sldMaster xmlns:a="http://schemas.openxmlformats.org/drawingml/2006/main" xmlns:r="http://schemas.openxmlformats.org/officeDocument/2006/relationships" xmlns:p="http://schemas.openxmlformats.org/presentationml/2006/main">
   <p:cSld>
+    <p:bg>
+      <p:bgRef idx="1001">
+        <a:schemeClr val="bg1"/>
+      </p:bgRef>
+    </p:bg>
     <p:spTree>
       <p:nvGrpSpPr>
         <p:cNvPr id="1" name=""/>
@@ -957,9 +740,11 @@
       <p:sp>
         <p:nvSpPr>
           <p:cNvPr id="2" name="Text 0"/>
-          <p:cNvSpPr/>
+          <p:cNvSpPr>
+            <a:spLocks noGrp="1"/>
+          </p:cNvSpPr>
           <p:nvPr>
-            <p:ph idx="100" type="title" hasCustomPrompt="1"/>
+            <p:ph type="title" idx="100" hasCustomPrompt="1"/>
           </p:nvPr>
         </p:nvSpPr>
         <p:spPr>
@@ -977,7 +762,7 @@
           <a:bodyPr wrap="square" lIns="0" tIns="0" rIns="0" bIns="0" rtlCol="0" anchor="ctr"/>
           <a:lstStyle/>
           <a:p>
-            <a:pPr algn="l" indent="0" marL="0">
+            <a:pPr marL="0" indent="0" algn="l">
               <a:buNone/>
             </a:pPr>
             <a:r>
@@ -1013,7 +798,7 @@
           <a:bodyPr wrap="square" lIns="0" tIns="0" rIns="0" bIns="0" rtlCol="0" anchor="ctr"/>
           <a:lstStyle/>
           <a:p>
-            <a:pPr indent="0" marL="0">
+            <a:pPr marL="0" indent="0">
               <a:buNone/>
             </a:pPr>
             <a:r>
@@ -1030,31 +815,55 @@
       </p:sp>
       <p:graphicFrame>
         <p:nvGraphicFramePr>
-          <p:cNvPr id="2" name="TechStackTable"/>
+          <p:cNvPr id="4" name="TechStackTable"/>
           <p:cNvGraphicFramePr>
             <a:graphicFrameLocks noGrp="1"/>
           </p:cNvGraphicFramePr>
           <p:nvPr>
             <p:extLst>
               <p:ext uri="{D42A27DB-BD31-4B8C-83A1-F6EECF244321}">
-                <p14:modId xmlns:p14="http://schemas.microsoft.com/office/powerpoint/2010/main" val="1579011935"/>
+                <p14:modId xmlns:p14="http://schemas.microsoft.com/office/powerpoint/2010/main" val="2070361726"/>
               </p:ext>
             </p:extLst>
           </p:nvPr>
         </p:nvGraphicFramePr>
         <p:xfrm>
           <a:off x="548640" y="1371600"/>
-          <a:ext cx="11091672" cy="914400"/>
+          <a:ext cx="11091672" cy="5020056"/>
         </p:xfrm>
         <a:graphic>
           <a:graphicData uri="http://schemas.openxmlformats.org/drawingml/2006/table">
             <a:tbl>
               <a:tblPr/>
               <a:tblGrid>
-                <a:gridCol w="1737360"/>
-                <a:gridCol w="2103120"/>
-                <a:gridCol w="4114800"/>
-                <a:gridCol w="3136392"/>
+                <a:gridCol w="1737360">
+                  <a:extLst>
+                    <a:ext uri="{9D8B030D-6E8A-4147-A177-3AD203B41FA5}">
+                      <a16:colId xmlns:a16="http://schemas.microsoft.com/office/drawing/2014/main" val="20000"/>
+                    </a:ext>
+                  </a:extLst>
+                </a:gridCol>
+                <a:gridCol w="2103120">
+                  <a:extLst>
+                    <a:ext uri="{9D8B030D-6E8A-4147-A177-3AD203B41FA5}">
+                      <a16:colId xmlns:a16="http://schemas.microsoft.com/office/drawing/2014/main" val="20001"/>
+                    </a:ext>
+                  </a:extLst>
+                </a:gridCol>
+                <a:gridCol w="3688080">
+                  <a:extLst>
+                    <a:ext uri="{9D8B030D-6E8A-4147-A177-3AD203B41FA5}">
+                      <a16:colId xmlns:a16="http://schemas.microsoft.com/office/drawing/2014/main" val="20002"/>
+                    </a:ext>
+                  </a:extLst>
+                </a:gridCol>
+                <a:gridCol w="3563112">
+                  <a:extLst>
+                    <a:ext uri="{9D8B030D-6E8A-4147-A177-3AD203B41FA5}">
+                      <a16:colId xmlns:a16="http://schemas.microsoft.com/office/drawing/2014/main" val="20003"/>
+                    </a:ext>
+                  </a:extLst>
+                </a:gridCol>
               </a:tblGrid>
               <a:tr h="411480">
                 <a:tc>
@@ -1062,7 +871,7 @@
                     <a:bodyPr/>
                     <a:lstStyle/>
                     <a:p>
-                      <a:pPr indent="0" marL="0">
+                      <a:pPr marL="0" indent="0">
                         <a:buNone/>
                       </a:pPr>
                       <a:r>
@@ -1118,7 +927,7 @@
                     <a:bodyPr/>
                     <a:lstStyle/>
                     <a:p>
-                      <a:pPr indent="0" marL="0">
+                      <a:pPr marL="0" indent="0">
                         <a:buNone/>
                       </a:pPr>
                       <a:r>
@@ -1174,7 +983,7 @@
                     <a:bodyPr/>
                     <a:lstStyle/>
                     <a:p>
-                      <a:pPr indent="0" marL="0">
+                      <a:pPr marL="0" indent="0">
                         <a:buNone/>
                       </a:pPr>
                       <a:r>
@@ -1230,7 +1039,7 @@
                     <a:bodyPr/>
                     <a:lstStyle/>
                     <a:p>
-                      <a:pPr indent="0" marL="0">
+                      <a:pPr marL="0" indent="0">
                         <a:buNone/>
                       </a:pPr>
                       <a:r>
@@ -1281,6 +1090,11 @@
                     </a:solidFill>
                   </a:tcPr>
                 </a:tc>
+                <a:extLst>
+                  <a:ext uri="{0D108BD9-81ED-4DB2-BD59-A6C34878D82A}">
+                    <a16:rowId xmlns:a16="http://schemas.microsoft.com/office/drawing/2014/main" val="10000"/>
+                  </a:ext>
+                </a:extLst>
               </a:tr>
               <a:tr h="512064">
                 <a:tc>
@@ -1288,7 +1102,7 @@
                     <a:bodyPr/>
                     <a:lstStyle/>
                     <a:p>
-                      <a:pPr indent="0" marL="0">
+                      <a:pPr marL="0" indent="0">
                         <a:buNone/>
                       </a:pPr>
                       <a:r>
@@ -1316,8 +1130,14 @@
                     <a:lnR w="0" cap="flat" cmpd="sng" algn="ctr">
                       <a:noFill/>
                     </a:lnR>
-                    <a:lnT w="0" cap="flat" cmpd="sng" algn="ctr">
-                      <a:noFill/>
+                    <a:lnT w="12700" cap="flat" cmpd="sng" algn="ctr">
+                      <a:solidFill>
+                        <a:srgbClr val="8C959F"/>
+                      </a:solidFill>
+                      <a:prstDash val="solid"/>
+                      <a:round/>
+                      <a:headEnd type="none" w="med" len="med"/>
+                      <a:tailEnd type="none" w="med" len="med"/>
                     </a:lnT>
                     <a:lnB w="9525" cap="flat" cmpd="sng" algn="ctr">
                       <a:solidFill>
@@ -1335,7 +1155,7 @@
                     <a:bodyPr/>
                     <a:lstStyle/>
                     <a:p>
-                      <a:pPr indent="0" marL="0">
+                      <a:pPr marL="0" indent="0">
                         <a:buNone/>
                       </a:pPr>
                       <a:endParaRPr lang="en-US" sz="1400" dirty="0">
@@ -1352,8 +1172,14 @@
                     <a:lnR w="0" cap="flat" cmpd="sng" algn="ctr">
                       <a:noFill/>
                     </a:lnR>
-                    <a:lnT w="0" cap="flat" cmpd="sng" algn="ctr">
-                      <a:noFill/>
+                    <a:lnT w="12700" cap="flat" cmpd="sng" algn="ctr">
+                      <a:solidFill>
+                        <a:srgbClr val="8C959F"/>
+                      </a:solidFill>
+                      <a:prstDash val="solid"/>
+                      <a:round/>
+                      <a:headEnd type="none" w="med" len="med"/>
+                      <a:tailEnd type="none" w="med" len="med"/>
                     </a:lnT>
                     <a:lnB w="9525" cap="flat" cmpd="sng" algn="ctr">
                       <a:solidFill>
@@ -1371,7 +1197,7 @@
                     <a:bodyPr/>
                     <a:lstStyle/>
                     <a:p>
-                      <a:pPr indent="0" marL="0">
+                      <a:pPr marL="0" indent="0">
                         <a:buNone/>
                       </a:pPr>
                       <a:r>
@@ -1399,8 +1225,14 @@
                     <a:lnR w="0" cap="flat" cmpd="sng" algn="ctr">
                       <a:noFill/>
                     </a:lnR>
-                    <a:lnT w="0" cap="flat" cmpd="sng" algn="ctr">
-                      <a:noFill/>
+                    <a:lnT w="12700" cap="flat" cmpd="sng" algn="ctr">
+                      <a:solidFill>
+                        <a:srgbClr val="8C959F"/>
+                      </a:solidFill>
+                      <a:prstDash val="solid"/>
+                      <a:round/>
+                      <a:headEnd type="none" w="med" len="med"/>
+                      <a:tailEnd type="none" w="med" len="med"/>
                     </a:lnT>
                     <a:lnB w="9525" cap="flat" cmpd="sng" algn="ctr">
                       <a:solidFill>
@@ -1418,7 +1250,7 @@
                     <a:bodyPr/>
                     <a:lstStyle/>
                     <a:p>
-                      <a:pPr indent="0" marL="0">
+                      <a:pPr marL="0" indent="0">
                         <a:buNone/>
                       </a:pPr>
                       <a:r>
@@ -1446,8 +1278,14 @@
                     <a:lnR w="0" cap="flat" cmpd="sng" algn="ctr">
                       <a:noFill/>
                     </a:lnR>
-                    <a:lnT w="0" cap="flat" cmpd="sng" algn="ctr">
-                      <a:noFill/>
+                    <a:lnT w="12700" cap="flat" cmpd="sng" algn="ctr">
+                      <a:solidFill>
+                        <a:srgbClr val="8C959F"/>
+                      </a:solidFill>
+                      <a:prstDash val="solid"/>
+                      <a:round/>
+                      <a:headEnd type="none" w="med" len="med"/>
+                      <a:tailEnd type="none" w="med" len="med"/>
                     </a:lnT>
                     <a:lnB w="9525" cap="flat" cmpd="sng" algn="ctr">
                       <a:solidFill>
@@ -1460,6 +1298,11 @@
                     </a:lnB>
                   </a:tcPr>
                 </a:tc>
+                <a:extLst>
+                  <a:ext uri="{0D108BD9-81ED-4DB2-BD59-A6C34878D82A}">
+                    <a16:rowId xmlns:a16="http://schemas.microsoft.com/office/drawing/2014/main" val="10001"/>
+                  </a:ext>
+                </a:extLst>
               </a:tr>
               <a:tr h="512064">
                 <a:tc>
@@ -1467,7 +1310,7 @@
                     <a:bodyPr/>
                     <a:lstStyle/>
                     <a:p>
-                      <a:pPr indent="0" marL="0">
+                      <a:pPr marL="0" indent="0">
                         <a:buNone/>
                       </a:pPr>
                       <a:r>
@@ -1495,8 +1338,14 @@
                     <a:lnR w="0" cap="flat" cmpd="sng" algn="ctr">
                       <a:noFill/>
                     </a:lnR>
-                    <a:lnT w="0" cap="flat" cmpd="sng" algn="ctr">
-                      <a:noFill/>
+                    <a:lnT w="9525" cap="flat" cmpd="sng" algn="ctr">
+                      <a:solidFill>
+                        <a:srgbClr val="D0D7DE"/>
+                      </a:solidFill>
+                      <a:prstDash val="solid"/>
+                      <a:round/>
+                      <a:headEnd type="none" w="med" len="med"/>
+                      <a:tailEnd type="none" w="med" len="med"/>
                     </a:lnT>
                     <a:lnB w="9525" cap="flat" cmpd="sng" algn="ctr">
                       <a:solidFill>
@@ -1514,7 +1363,7 @@
                     <a:bodyPr/>
                     <a:lstStyle/>
                     <a:p>
-                      <a:pPr indent="0" marL="0">
+                      <a:pPr marL="0" indent="0">
                         <a:buNone/>
                       </a:pPr>
                       <a:endParaRPr lang="en-US" sz="1400" dirty="0">
@@ -1531,8 +1380,14 @@
                     <a:lnR w="0" cap="flat" cmpd="sng" algn="ctr">
                       <a:noFill/>
                     </a:lnR>
-                    <a:lnT w="0" cap="flat" cmpd="sng" algn="ctr">
-                      <a:noFill/>
+                    <a:lnT w="9525" cap="flat" cmpd="sng" algn="ctr">
+                      <a:solidFill>
+                        <a:srgbClr val="D0D7DE"/>
+                      </a:solidFill>
+                      <a:prstDash val="solid"/>
+                      <a:round/>
+                      <a:headEnd type="none" w="med" len="med"/>
+                      <a:tailEnd type="none" w="med" len="med"/>
                     </a:lnT>
                     <a:lnB w="9525" cap="flat" cmpd="sng" algn="ctr">
                       <a:solidFill>
@@ -1550,7 +1405,7 @@
                     <a:bodyPr/>
                     <a:lstStyle/>
                     <a:p>
-                      <a:pPr indent="0" marL="0">
+                      <a:pPr marL="0" indent="0">
                         <a:buNone/>
                       </a:pPr>
                       <a:r>
@@ -1578,8 +1433,14 @@
                     <a:lnR w="0" cap="flat" cmpd="sng" algn="ctr">
                       <a:noFill/>
                     </a:lnR>
-                    <a:lnT w="0" cap="flat" cmpd="sng" algn="ctr">
-                      <a:noFill/>
+                    <a:lnT w="9525" cap="flat" cmpd="sng" algn="ctr">
+                      <a:solidFill>
+                        <a:srgbClr val="D0D7DE"/>
+                      </a:solidFill>
+                      <a:prstDash val="solid"/>
+                      <a:round/>
+                      <a:headEnd type="none" w="med" len="med"/>
+                      <a:tailEnd type="none" w="med" len="med"/>
                     </a:lnT>
                     <a:lnB w="9525" cap="flat" cmpd="sng" algn="ctr">
                       <a:solidFill>
@@ -1597,7 +1458,7 @@
                     <a:bodyPr/>
                     <a:lstStyle/>
                     <a:p>
-                      <a:pPr indent="0" marL="0">
+                      <a:pPr marL="0" indent="0">
                         <a:buNone/>
                       </a:pPr>
                       <a:r>
@@ -1625,8 +1486,14 @@
                     <a:lnR w="0" cap="flat" cmpd="sng" algn="ctr">
                       <a:noFill/>
                     </a:lnR>
-                    <a:lnT w="0" cap="flat" cmpd="sng" algn="ctr">
-                      <a:noFill/>
+                    <a:lnT w="9525" cap="flat" cmpd="sng" algn="ctr">
+                      <a:solidFill>
+                        <a:srgbClr val="D0D7DE"/>
+                      </a:solidFill>
+                      <a:prstDash val="solid"/>
+                      <a:round/>
+                      <a:headEnd type="none" w="med" len="med"/>
+                      <a:tailEnd type="none" w="med" len="med"/>
                     </a:lnT>
                     <a:lnB w="9525" cap="flat" cmpd="sng" algn="ctr">
                       <a:solidFill>
@@ -1639,6 +1506,11 @@
                     </a:lnB>
                   </a:tcPr>
                 </a:tc>
+                <a:extLst>
+                  <a:ext uri="{0D108BD9-81ED-4DB2-BD59-A6C34878D82A}">
+                    <a16:rowId xmlns:a16="http://schemas.microsoft.com/office/drawing/2014/main" val="10002"/>
+                  </a:ext>
+                </a:extLst>
               </a:tr>
               <a:tr h="512064">
                 <a:tc>
@@ -1646,7 +1518,7 @@
                     <a:bodyPr/>
                     <a:lstStyle/>
                     <a:p>
-                      <a:pPr indent="0" marL="0">
+                      <a:pPr marL="0" indent="0">
                         <a:buNone/>
                       </a:pPr>
                       <a:r>
@@ -1674,8 +1546,14 @@
                     <a:lnR w="0" cap="flat" cmpd="sng" algn="ctr">
                       <a:noFill/>
                     </a:lnR>
-                    <a:lnT w="0" cap="flat" cmpd="sng" algn="ctr">
-                      <a:noFill/>
+                    <a:lnT w="9525" cap="flat" cmpd="sng" algn="ctr">
+                      <a:solidFill>
+                        <a:srgbClr val="D0D7DE"/>
+                      </a:solidFill>
+                      <a:prstDash val="solid"/>
+                      <a:round/>
+                      <a:headEnd type="none" w="med" len="med"/>
+                      <a:tailEnd type="none" w="med" len="med"/>
                     </a:lnT>
                     <a:lnB w="9525" cap="flat" cmpd="sng" algn="ctr">
                       <a:solidFill>
@@ -1693,7 +1571,7 @@
                     <a:bodyPr/>
                     <a:lstStyle/>
                     <a:p>
-                      <a:pPr indent="0" marL="0">
+                      <a:pPr marL="0" indent="0">
                         <a:buNone/>
                       </a:pPr>
                       <a:endParaRPr lang="en-US" sz="1400" dirty="0">
@@ -1710,8 +1588,14 @@
                     <a:lnR w="0" cap="flat" cmpd="sng" algn="ctr">
                       <a:noFill/>
                     </a:lnR>
-                    <a:lnT w="0" cap="flat" cmpd="sng" algn="ctr">
-                      <a:noFill/>
+                    <a:lnT w="9525" cap="flat" cmpd="sng" algn="ctr">
+                      <a:solidFill>
+                        <a:srgbClr val="D0D7DE"/>
+                      </a:solidFill>
+                      <a:prstDash val="solid"/>
+                      <a:round/>
+                      <a:headEnd type="none" w="med" len="med"/>
+                      <a:tailEnd type="none" w="med" len="med"/>
                     </a:lnT>
                     <a:lnB w="9525" cap="flat" cmpd="sng" algn="ctr">
                       <a:solidFill>
@@ -1729,7 +1613,7 @@
                     <a:bodyPr/>
                     <a:lstStyle/>
                     <a:p>
-                      <a:pPr indent="0" marL="0">
+                      <a:pPr marL="0" indent="0">
                         <a:buNone/>
                       </a:pPr>
                       <a:r>
@@ -1757,8 +1641,14 @@
                     <a:lnR w="0" cap="flat" cmpd="sng" algn="ctr">
                       <a:noFill/>
                     </a:lnR>
-                    <a:lnT w="0" cap="flat" cmpd="sng" algn="ctr">
-                      <a:noFill/>
+                    <a:lnT w="9525" cap="flat" cmpd="sng" algn="ctr">
+                      <a:solidFill>
+                        <a:srgbClr val="D0D7DE"/>
+                      </a:solidFill>
+                      <a:prstDash val="solid"/>
+                      <a:round/>
+                      <a:headEnd type="none" w="med" len="med"/>
+                      <a:tailEnd type="none" w="med" len="med"/>
                     </a:lnT>
                     <a:lnB w="9525" cap="flat" cmpd="sng" algn="ctr">
                       <a:solidFill>
@@ -1776,7 +1666,7 @@
                     <a:bodyPr/>
                     <a:lstStyle/>
                     <a:p>
-                      <a:pPr indent="0" marL="0">
+                      <a:pPr marL="0" indent="0">
                         <a:buNone/>
                       </a:pPr>
                       <a:r>
@@ -1804,8 +1694,14 @@
                     <a:lnR w="0" cap="flat" cmpd="sng" algn="ctr">
                       <a:noFill/>
                     </a:lnR>
-                    <a:lnT w="0" cap="flat" cmpd="sng" algn="ctr">
-                      <a:noFill/>
+                    <a:lnT w="9525" cap="flat" cmpd="sng" algn="ctr">
+                      <a:solidFill>
+                        <a:srgbClr val="D0D7DE"/>
+                      </a:solidFill>
+                      <a:prstDash val="solid"/>
+                      <a:round/>
+                      <a:headEnd type="none" w="med" len="med"/>
+                      <a:tailEnd type="none" w="med" len="med"/>
                     </a:lnT>
                     <a:lnB w="9525" cap="flat" cmpd="sng" algn="ctr">
                       <a:solidFill>
@@ -1818,6 +1714,11 @@
                     </a:lnB>
                   </a:tcPr>
                 </a:tc>
+                <a:extLst>
+                  <a:ext uri="{0D108BD9-81ED-4DB2-BD59-A6C34878D82A}">
+                    <a16:rowId xmlns:a16="http://schemas.microsoft.com/office/drawing/2014/main" val="10003"/>
+                  </a:ext>
+                </a:extLst>
               </a:tr>
               <a:tr h="512064">
                 <a:tc>
@@ -1825,7 +1726,7 @@
                     <a:bodyPr/>
                     <a:lstStyle/>
                     <a:p>
-                      <a:pPr indent="0" marL="0">
+                      <a:pPr marL="0" indent="0">
                         <a:buNone/>
                       </a:pPr>
                       <a:r>
@@ -1853,8 +1754,14 @@
                     <a:lnR w="0" cap="flat" cmpd="sng" algn="ctr">
                       <a:noFill/>
                     </a:lnR>
-                    <a:lnT w="0" cap="flat" cmpd="sng" algn="ctr">
-                      <a:noFill/>
+                    <a:lnT w="9525" cap="flat" cmpd="sng" algn="ctr">
+                      <a:solidFill>
+                        <a:srgbClr val="D0D7DE"/>
+                      </a:solidFill>
+                      <a:prstDash val="solid"/>
+                      <a:round/>
+                      <a:headEnd type="none" w="med" len="med"/>
+                      <a:tailEnd type="none" w="med" len="med"/>
                     </a:lnT>
                     <a:lnB w="9525" cap="flat" cmpd="sng" algn="ctr">
                       <a:solidFill>
@@ -1872,7 +1779,7 @@
                     <a:bodyPr/>
                     <a:lstStyle/>
                     <a:p>
-                      <a:pPr indent="0" marL="0">
+                      <a:pPr marL="0" indent="0">
                         <a:buNone/>
                       </a:pPr>
                       <a:endParaRPr lang="en-US" sz="1400" dirty="0">
@@ -1889,8 +1796,14 @@
                     <a:lnR w="0" cap="flat" cmpd="sng" algn="ctr">
                       <a:noFill/>
                     </a:lnR>
-                    <a:lnT w="0" cap="flat" cmpd="sng" algn="ctr">
-                      <a:noFill/>
+                    <a:lnT w="9525" cap="flat" cmpd="sng" algn="ctr">
+                      <a:solidFill>
+                        <a:srgbClr val="D0D7DE"/>
+                      </a:solidFill>
+                      <a:prstDash val="solid"/>
+                      <a:round/>
+                      <a:headEnd type="none" w="med" len="med"/>
+                      <a:tailEnd type="none" w="med" len="med"/>
                     </a:lnT>
                     <a:lnB w="9525" cap="flat" cmpd="sng" algn="ctr">
                       <a:solidFill>
@@ -1908,7 +1821,7 @@
                     <a:bodyPr/>
                     <a:lstStyle/>
                     <a:p>
-                      <a:pPr indent="0" marL="0">
+                      <a:pPr marL="0" indent="0">
                         <a:buNone/>
                       </a:pPr>
                       <a:r>
@@ -1936,8 +1849,14 @@
                     <a:lnR w="0" cap="flat" cmpd="sng" algn="ctr">
                       <a:noFill/>
                     </a:lnR>
-                    <a:lnT w="0" cap="flat" cmpd="sng" algn="ctr">
-                      <a:noFill/>
+                    <a:lnT w="9525" cap="flat" cmpd="sng" algn="ctr">
+                      <a:solidFill>
+                        <a:srgbClr val="D0D7DE"/>
+                      </a:solidFill>
+                      <a:prstDash val="solid"/>
+                      <a:round/>
+                      <a:headEnd type="none" w="med" len="med"/>
+                      <a:tailEnd type="none" w="med" len="med"/>
                     </a:lnT>
                     <a:lnB w="9525" cap="flat" cmpd="sng" algn="ctr">
                       <a:solidFill>
@@ -1955,7 +1874,7 @@
                     <a:bodyPr/>
                     <a:lstStyle/>
                     <a:p>
-                      <a:pPr indent="0" marL="0">
+                      <a:pPr marL="0" indent="0">
                         <a:buNone/>
                       </a:pPr>
                       <a:r>
@@ -1983,8 +1902,14 @@
                     <a:lnR w="0" cap="flat" cmpd="sng" algn="ctr">
                       <a:noFill/>
                     </a:lnR>
-                    <a:lnT w="0" cap="flat" cmpd="sng" algn="ctr">
-                      <a:noFill/>
+                    <a:lnT w="9525" cap="flat" cmpd="sng" algn="ctr">
+                      <a:solidFill>
+                        <a:srgbClr val="D0D7DE"/>
+                      </a:solidFill>
+                      <a:prstDash val="solid"/>
+                      <a:round/>
+                      <a:headEnd type="none" w="med" len="med"/>
+                      <a:tailEnd type="none" w="med" len="med"/>
                     </a:lnT>
                     <a:lnB w="9525" cap="flat" cmpd="sng" algn="ctr">
                       <a:solidFill>
@@ -1997,6 +1922,11 @@
                     </a:lnB>
                   </a:tcPr>
                 </a:tc>
+                <a:extLst>
+                  <a:ext uri="{0D108BD9-81ED-4DB2-BD59-A6C34878D82A}">
+                    <a16:rowId xmlns:a16="http://schemas.microsoft.com/office/drawing/2014/main" val="10004"/>
+                  </a:ext>
+                </a:extLst>
               </a:tr>
               <a:tr h="512064">
                 <a:tc>
@@ -2004,7 +1934,7 @@
                     <a:bodyPr/>
                     <a:lstStyle/>
                     <a:p>
-                      <a:pPr indent="0" marL="0">
+                      <a:pPr marL="0" indent="0">
                         <a:buNone/>
                       </a:pPr>
                       <a:r>
@@ -2032,8 +1962,14 @@
                     <a:lnR w="0" cap="flat" cmpd="sng" algn="ctr">
                       <a:noFill/>
                     </a:lnR>
-                    <a:lnT w="0" cap="flat" cmpd="sng" algn="ctr">
-                      <a:noFill/>
+                    <a:lnT w="9525" cap="flat" cmpd="sng" algn="ctr">
+                      <a:solidFill>
+                        <a:srgbClr val="D0D7DE"/>
+                      </a:solidFill>
+                      <a:prstDash val="solid"/>
+                      <a:round/>
+                      <a:headEnd type="none" w="med" len="med"/>
+                      <a:tailEnd type="none" w="med" len="med"/>
                     </a:lnT>
                     <a:lnB w="9525" cap="flat" cmpd="sng" algn="ctr">
                       <a:solidFill>
@@ -2051,7 +1987,7 @@
                     <a:bodyPr/>
                     <a:lstStyle/>
                     <a:p>
-                      <a:pPr indent="0" marL="0">
+                      <a:pPr marL="0" indent="0">
                         <a:buNone/>
                       </a:pPr>
                       <a:endParaRPr lang="en-US" sz="1400" dirty="0">
@@ -2068,8 +2004,14 @@
                     <a:lnR w="0" cap="flat" cmpd="sng" algn="ctr">
                       <a:noFill/>
                     </a:lnR>
-                    <a:lnT w="0" cap="flat" cmpd="sng" algn="ctr">
-                      <a:noFill/>
+                    <a:lnT w="9525" cap="flat" cmpd="sng" algn="ctr">
+                      <a:solidFill>
+                        <a:srgbClr val="D0D7DE"/>
+                      </a:solidFill>
+                      <a:prstDash val="solid"/>
+                      <a:round/>
+                      <a:headEnd type="none" w="med" len="med"/>
+                      <a:tailEnd type="none" w="med" len="med"/>
                     </a:lnT>
                     <a:lnB w="9525" cap="flat" cmpd="sng" algn="ctr">
                       <a:solidFill>
@@ -2087,7 +2029,7 @@
                     <a:bodyPr/>
                     <a:lstStyle/>
                     <a:p>
-                      <a:pPr indent="0" marL="0">
+                      <a:pPr marL="0" indent="0">
                         <a:buNone/>
                       </a:pPr>
                       <a:r>
@@ -2115,8 +2057,14 @@
                     <a:lnR w="0" cap="flat" cmpd="sng" algn="ctr">
                       <a:noFill/>
                     </a:lnR>
-                    <a:lnT w="0" cap="flat" cmpd="sng" algn="ctr">
-                      <a:noFill/>
+                    <a:lnT w="9525" cap="flat" cmpd="sng" algn="ctr">
+                      <a:solidFill>
+                        <a:srgbClr val="D0D7DE"/>
+                      </a:solidFill>
+                      <a:prstDash val="solid"/>
+                      <a:round/>
+                      <a:headEnd type="none" w="med" len="med"/>
+                      <a:tailEnd type="none" w="med" len="med"/>
                     </a:lnT>
                     <a:lnB w="9525" cap="flat" cmpd="sng" algn="ctr">
                       <a:solidFill>
@@ -2134,7 +2082,7 @@
                     <a:bodyPr/>
                     <a:lstStyle/>
                     <a:p>
-                      <a:pPr indent="0" marL="0">
+                      <a:pPr marL="0" indent="0">
                         <a:buNone/>
                       </a:pPr>
                       <a:r>
@@ -2162,8 +2110,14 @@
                     <a:lnR w="0" cap="flat" cmpd="sng" algn="ctr">
                       <a:noFill/>
                     </a:lnR>
-                    <a:lnT w="0" cap="flat" cmpd="sng" algn="ctr">
-                      <a:noFill/>
+                    <a:lnT w="9525" cap="flat" cmpd="sng" algn="ctr">
+                      <a:solidFill>
+                        <a:srgbClr val="D0D7DE"/>
+                      </a:solidFill>
+                      <a:prstDash val="solid"/>
+                      <a:round/>
+                      <a:headEnd type="none" w="med" len="med"/>
+                      <a:tailEnd type="none" w="med" len="med"/>
                     </a:lnT>
                     <a:lnB w="9525" cap="flat" cmpd="sng" algn="ctr">
                       <a:solidFill>
@@ -2176,6 +2130,11 @@
                     </a:lnB>
                   </a:tcPr>
                 </a:tc>
+                <a:extLst>
+                  <a:ext uri="{0D108BD9-81ED-4DB2-BD59-A6C34878D82A}">
+                    <a16:rowId xmlns:a16="http://schemas.microsoft.com/office/drawing/2014/main" val="10005"/>
+                  </a:ext>
+                </a:extLst>
               </a:tr>
               <a:tr h="512064">
                 <a:tc>
@@ -2183,7 +2142,7 @@
                     <a:bodyPr/>
                     <a:lstStyle/>
                     <a:p>
-                      <a:pPr indent="0" marL="0">
+                      <a:pPr marL="0" indent="0">
                         <a:buNone/>
                       </a:pPr>
                       <a:r>
@@ -2211,8 +2170,14 @@
                     <a:lnR w="0" cap="flat" cmpd="sng" algn="ctr">
                       <a:noFill/>
                     </a:lnR>
-                    <a:lnT w="0" cap="flat" cmpd="sng" algn="ctr">
-                      <a:noFill/>
+                    <a:lnT w="9525" cap="flat" cmpd="sng" algn="ctr">
+                      <a:solidFill>
+                        <a:srgbClr val="D0D7DE"/>
+                      </a:solidFill>
+                      <a:prstDash val="solid"/>
+                      <a:round/>
+                      <a:headEnd type="none" w="med" len="med"/>
+                      <a:tailEnd type="none" w="med" len="med"/>
                     </a:lnT>
                     <a:lnB w="9525" cap="flat" cmpd="sng" algn="ctr">
                       <a:solidFill>
@@ -2230,7 +2195,7 @@
                     <a:bodyPr/>
                     <a:lstStyle/>
                     <a:p>
-                      <a:pPr indent="0" marL="0">
+                      <a:pPr marL="0" indent="0">
                         <a:buNone/>
                       </a:pPr>
                       <a:endParaRPr lang="en-US" sz="1400" dirty="0">
@@ -2247,8 +2212,14 @@
                     <a:lnR w="0" cap="flat" cmpd="sng" algn="ctr">
                       <a:noFill/>
                     </a:lnR>
-                    <a:lnT w="0" cap="flat" cmpd="sng" algn="ctr">
-                      <a:noFill/>
+                    <a:lnT w="9525" cap="flat" cmpd="sng" algn="ctr">
+                      <a:solidFill>
+                        <a:srgbClr val="D0D7DE"/>
+                      </a:solidFill>
+                      <a:prstDash val="solid"/>
+                      <a:round/>
+                      <a:headEnd type="none" w="med" len="med"/>
+                      <a:tailEnd type="none" w="med" len="med"/>
                     </a:lnT>
                     <a:lnB w="9525" cap="flat" cmpd="sng" algn="ctr">
                       <a:solidFill>
@@ -2266,7 +2237,7 @@
                     <a:bodyPr/>
                     <a:lstStyle/>
                     <a:p>
-                      <a:pPr indent="0" marL="0">
+                      <a:pPr marL="0" indent="0">
                         <a:buNone/>
                       </a:pPr>
                       <a:r>
@@ -2294,8 +2265,14 @@
                     <a:lnR w="0" cap="flat" cmpd="sng" algn="ctr">
                       <a:noFill/>
                     </a:lnR>
-                    <a:lnT w="0" cap="flat" cmpd="sng" algn="ctr">
-                      <a:noFill/>
+                    <a:lnT w="9525" cap="flat" cmpd="sng" algn="ctr">
+                      <a:solidFill>
+                        <a:srgbClr val="D0D7DE"/>
+                      </a:solidFill>
+                      <a:prstDash val="solid"/>
+                      <a:round/>
+                      <a:headEnd type="none" w="med" len="med"/>
+                      <a:tailEnd type="none" w="med" len="med"/>
                     </a:lnT>
                     <a:lnB w="9525" cap="flat" cmpd="sng" algn="ctr">
                       <a:solidFill>
@@ -2313,7 +2290,7 @@
                     <a:bodyPr/>
                     <a:lstStyle/>
                     <a:p>
-                      <a:pPr indent="0" marL="0">
+                      <a:pPr marL="0" indent="0">
                         <a:buNone/>
                       </a:pPr>
                       <a:r>
@@ -2341,8 +2318,14 @@
                     <a:lnR w="0" cap="flat" cmpd="sng" algn="ctr">
                       <a:noFill/>
                     </a:lnR>
-                    <a:lnT w="0" cap="flat" cmpd="sng" algn="ctr">
-                      <a:noFill/>
+                    <a:lnT w="9525" cap="flat" cmpd="sng" algn="ctr">
+                      <a:solidFill>
+                        <a:srgbClr val="D0D7DE"/>
+                      </a:solidFill>
+                      <a:prstDash val="solid"/>
+                      <a:round/>
+                      <a:headEnd type="none" w="med" len="med"/>
+                      <a:tailEnd type="none" w="med" len="med"/>
                     </a:lnT>
                     <a:lnB w="9525" cap="flat" cmpd="sng" algn="ctr">
                       <a:solidFill>
@@ -2355,6 +2338,11 @@
                     </a:lnB>
                   </a:tcPr>
                 </a:tc>
+                <a:extLst>
+                  <a:ext uri="{0D108BD9-81ED-4DB2-BD59-A6C34878D82A}">
+                    <a16:rowId xmlns:a16="http://schemas.microsoft.com/office/drawing/2014/main" val="10006"/>
+                  </a:ext>
+                </a:extLst>
               </a:tr>
               <a:tr h="512064">
                 <a:tc>
@@ -2362,7 +2350,7 @@
                     <a:bodyPr/>
                     <a:lstStyle/>
                     <a:p>
-                      <a:pPr indent="0" marL="0">
+                      <a:pPr marL="0" indent="0">
                         <a:buNone/>
                       </a:pPr>
                       <a:r>
@@ -2390,8 +2378,14 @@
                     <a:lnR w="0" cap="flat" cmpd="sng" algn="ctr">
                       <a:noFill/>
                     </a:lnR>
-                    <a:lnT w="0" cap="flat" cmpd="sng" algn="ctr">
-                      <a:noFill/>
+                    <a:lnT w="9525" cap="flat" cmpd="sng" algn="ctr">
+                      <a:solidFill>
+                        <a:srgbClr val="D0D7DE"/>
+                      </a:solidFill>
+                      <a:prstDash val="solid"/>
+                      <a:round/>
+                      <a:headEnd type="none" w="med" len="med"/>
+                      <a:tailEnd type="none" w="med" len="med"/>
                     </a:lnT>
                     <a:lnB w="9525" cap="flat" cmpd="sng" algn="ctr">
                       <a:solidFill>
@@ -2409,7 +2403,7 @@
                     <a:bodyPr/>
                     <a:lstStyle/>
                     <a:p>
-                      <a:pPr indent="0" marL="0">
+                      <a:pPr marL="0" indent="0">
                         <a:buNone/>
                       </a:pPr>
                       <a:endParaRPr lang="en-US" sz="1400" dirty="0">
@@ -2426,8 +2420,14 @@
                     <a:lnR w="0" cap="flat" cmpd="sng" algn="ctr">
                       <a:noFill/>
                     </a:lnR>
-                    <a:lnT w="0" cap="flat" cmpd="sng" algn="ctr">
-                      <a:noFill/>
+                    <a:lnT w="9525" cap="flat" cmpd="sng" algn="ctr">
+                      <a:solidFill>
+                        <a:srgbClr val="D0D7DE"/>
+                      </a:solidFill>
+                      <a:prstDash val="solid"/>
+                      <a:round/>
+                      <a:headEnd type="none" w="med" len="med"/>
+                      <a:tailEnd type="none" w="med" len="med"/>
                     </a:lnT>
                     <a:lnB w="9525" cap="flat" cmpd="sng" algn="ctr">
                       <a:solidFill>
@@ -2445,7 +2445,7 @@
                     <a:bodyPr/>
                     <a:lstStyle/>
                     <a:p>
-                      <a:pPr indent="0" marL="0">
+                      <a:pPr marL="0" indent="0">
                         <a:buNone/>
                       </a:pPr>
                       <a:r>
@@ -2473,8 +2473,14 @@
                     <a:lnR w="0" cap="flat" cmpd="sng" algn="ctr">
                       <a:noFill/>
                     </a:lnR>
-                    <a:lnT w="0" cap="flat" cmpd="sng" algn="ctr">
-                      <a:noFill/>
+                    <a:lnT w="9525" cap="flat" cmpd="sng" algn="ctr">
+                      <a:solidFill>
+                        <a:srgbClr val="D0D7DE"/>
+                      </a:solidFill>
+                      <a:prstDash val="solid"/>
+                      <a:round/>
+                      <a:headEnd type="none" w="med" len="med"/>
+                      <a:tailEnd type="none" w="med" len="med"/>
                     </a:lnT>
                     <a:lnB w="9525" cap="flat" cmpd="sng" algn="ctr">
                       <a:solidFill>
@@ -2492,7 +2498,7 @@
                     <a:bodyPr/>
                     <a:lstStyle/>
                     <a:p>
-                      <a:pPr indent="0" marL="0">
+                      <a:pPr marL="0" indent="0">
                         <a:buNone/>
                       </a:pPr>
                       <a:r>
@@ -2520,8 +2526,14 @@
                     <a:lnR w="0" cap="flat" cmpd="sng" algn="ctr">
                       <a:noFill/>
                     </a:lnR>
-                    <a:lnT w="0" cap="flat" cmpd="sng" algn="ctr">
-                      <a:noFill/>
+                    <a:lnT w="9525" cap="flat" cmpd="sng" algn="ctr">
+                      <a:solidFill>
+                        <a:srgbClr val="D0D7DE"/>
+                      </a:solidFill>
+                      <a:prstDash val="solid"/>
+                      <a:round/>
+                      <a:headEnd type="none" w="med" len="med"/>
+                      <a:tailEnd type="none" w="med" len="med"/>
                     </a:lnT>
                     <a:lnB w="9525" cap="flat" cmpd="sng" algn="ctr">
                       <a:solidFill>
@@ -2534,6 +2546,11 @@
                     </a:lnB>
                   </a:tcPr>
                 </a:tc>
+                <a:extLst>
+                  <a:ext uri="{0D108BD9-81ED-4DB2-BD59-A6C34878D82A}">
+                    <a16:rowId xmlns:a16="http://schemas.microsoft.com/office/drawing/2014/main" val="10007"/>
+                  </a:ext>
+                </a:extLst>
               </a:tr>
               <a:tr h="512064">
                 <a:tc>
@@ -2541,7 +2558,7 @@
                     <a:bodyPr/>
                     <a:lstStyle/>
                     <a:p>
-                      <a:pPr indent="0" marL="0">
+                      <a:pPr marL="0" indent="0">
                         <a:buNone/>
                       </a:pPr>
                       <a:r>
@@ -2569,8 +2586,14 @@
                     <a:lnR w="0" cap="flat" cmpd="sng" algn="ctr">
                       <a:noFill/>
                     </a:lnR>
-                    <a:lnT w="0" cap="flat" cmpd="sng" algn="ctr">
-                      <a:noFill/>
+                    <a:lnT w="9525" cap="flat" cmpd="sng" algn="ctr">
+                      <a:solidFill>
+                        <a:srgbClr val="D0D7DE"/>
+                      </a:solidFill>
+                      <a:prstDash val="solid"/>
+                      <a:round/>
+                      <a:headEnd type="none" w="med" len="med"/>
+                      <a:tailEnd type="none" w="med" len="med"/>
                     </a:lnT>
                     <a:lnB w="9525" cap="flat" cmpd="sng" algn="ctr">
                       <a:solidFill>
@@ -2588,7 +2611,7 @@
                     <a:bodyPr/>
                     <a:lstStyle/>
                     <a:p>
-                      <a:pPr indent="0" marL="0">
+                      <a:pPr marL="0" indent="0">
                         <a:buNone/>
                       </a:pPr>
                       <a:endParaRPr lang="en-US" sz="1400" dirty="0">
@@ -2605,8 +2628,14 @@
                     <a:lnR w="0" cap="flat" cmpd="sng" algn="ctr">
                       <a:noFill/>
                     </a:lnR>
-                    <a:lnT w="0" cap="flat" cmpd="sng" algn="ctr">
-                      <a:noFill/>
+                    <a:lnT w="9525" cap="flat" cmpd="sng" algn="ctr">
+                      <a:solidFill>
+                        <a:srgbClr val="D0D7DE"/>
+                      </a:solidFill>
+                      <a:prstDash val="solid"/>
+                      <a:round/>
+                      <a:headEnd type="none" w="med" len="med"/>
+                      <a:tailEnd type="none" w="med" len="med"/>
                     </a:lnT>
                     <a:lnB w="9525" cap="flat" cmpd="sng" algn="ctr">
                       <a:solidFill>
@@ -2624,7 +2653,7 @@
                     <a:bodyPr/>
                     <a:lstStyle/>
                     <a:p>
-                      <a:pPr indent="0" marL="0">
+                      <a:pPr marL="0" indent="0">
                         <a:buNone/>
                       </a:pPr>
                       <a:r>
@@ -2652,8 +2681,14 @@
                     <a:lnR w="0" cap="flat" cmpd="sng" algn="ctr">
                       <a:noFill/>
                     </a:lnR>
-                    <a:lnT w="0" cap="flat" cmpd="sng" algn="ctr">
-                      <a:noFill/>
+                    <a:lnT w="9525" cap="flat" cmpd="sng" algn="ctr">
+                      <a:solidFill>
+                        <a:srgbClr val="D0D7DE"/>
+                      </a:solidFill>
+                      <a:prstDash val="solid"/>
+                      <a:round/>
+                      <a:headEnd type="none" w="med" len="med"/>
+                      <a:tailEnd type="none" w="med" len="med"/>
                     </a:lnT>
                     <a:lnB w="9525" cap="flat" cmpd="sng" algn="ctr">
                       <a:solidFill>
@@ -2671,7 +2706,7 @@
                     <a:bodyPr/>
                     <a:lstStyle/>
                     <a:p>
-                      <a:pPr indent="0" marL="0">
+                      <a:pPr marL="0" indent="0">
                         <a:buNone/>
                       </a:pPr>
                       <a:r>
@@ -2699,8 +2734,14 @@
                     <a:lnR w="0" cap="flat" cmpd="sng" algn="ctr">
                       <a:noFill/>
                     </a:lnR>
-                    <a:lnT w="0" cap="flat" cmpd="sng" algn="ctr">
-                      <a:noFill/>
+                    <a:lnT w="9525" cap="flat" cmpd="sng" algn="ctr">
+                      <a:solidFill>
+                        <a:srgbClr val="D0D7DE"/>
+                      </a:solidFill>
+                      <a:prstDash val="solid"/>
+                      <a:round/>
+                      <a:headEnd type="none" w="med" len="med"/>
+                      <a:tailEnd type="none" w="med" len="med"/>
                     </a:lnT>
                     <a:lnB w="9525" cap="flat" cmpd="sng" algn="ctr">
                       <a:solidFill>
@@ -2713,6 +2754,11 @@
                     </a:lnB>
                   </a:tcPr>
                 </a:tc>
+                <a:extLst>
+                  <a:ext uri="{0D108BD9-81ED-4DB2-BD59-A6C34878D82A}">
+                    <a16:rowId xmlns:a16="http://schemas.microsoft.com/office/drawing/2014/main" val="10008"/>
+                  </a:ext>
+                </a:extLst>
               </a:tr>
               <a:tr h="512064">
                 <a:tc>
@@ -2720,7 +2766,7 @@
                     <a:bodyPr/>
                     <a:lstStyle/>
                     <a:p>
-                      <a:pPr indent="0" marL="0">
+                      <a:pPr marL="0" indent="0">
                         <a:buNone/>
                       </a:pPr>
                       <a:r>
@@ -2748,8 +2794,14 @@
                     <a:lnR w="0" cap="flat" cmpd="sng" algn="ctr">
                       <a:noFill/>
                     </a:lnR>
-                    <a:lnT w="0" cap="flat" cmpd="sng" algn="ctr">
-                      <a:noFill/>
+                    <a:lnT w="9525" cap="flat" cmpd="sng" algn="ctr">
+                      <a:solidFill>
+                        <a:srgbClr val="D0D7DE"/>
+                      </a:solidFill>
+                      <a:prstDash val="solid"/>
+                      <a:round/>
+                      <a:headEnd type="none" w="med" len="med"/>
+                      <a:tailEnd type="none" w="med" len="med"/>
                     </a:lnT>
                     <a:lnB w="9525" cap="flat" cmpd="sng" algn="ctr">
                       <a:solidFill>
@@ -2767,7 +2819,7 @@
                     <a:bodyPr/>
                     <a:lstStyle/>
                     <a:p>
-                      <a:pPr indent="0" marL="0">
+                      <a:pPr marL="0" indent="0">
                         <a:buNone/>
                       </a:pPr>
                       <a:endParaRPr lang="en-US" sz="1400" dirty="0">
@@ -2784,8 +2836,14 @@
                     <a:lnR w="0" cap="flat" cmpd="sng" algn="ctr">
                       <a:noFill/>
                     </a:lnR>
-                    <a:lnT w="0" cap="flat" cmpd="sng" algn="ctr">
-                      <a:noFill/>
+                    <a:lnT w="9525" cap="flat" cmpd="sng" algn="ctr">
+                      <a:solidFill>
+                        <a:srgbClr val="D0D7DE"/>
+                      </a:solidFill>
+                      <a:prstDash val="solid"/>
+                      <a:round/>
+                      <a:headEnd type="none" w="med" len="med"/>
+                      <a:tailEnd type="none" w="med" len="med"/>
                     </a:lnT>
                     <a:lnB w="9525" cap="flat" cmpd="sng" algn="ctr">
                       <a:solidFill>
@@ -2803,7 +2861,7 @@
                     <a:bodyPr/>
                     <a:lstStyle/>
                     <a:p>
-                      <a:pPr indent="0" marL="0">
+                      <a:pPr marL="0" indent="0">
                         <a:buNone/>
                       </a:pPr>
                       <a:r>
@@ -2831,8 +2889,14 @@
                     <a:lnR w="0" cap="flat" cmpd="sng" algn="ctr">
                       <a:noFill/>
                     </a:lnR>
-                    <a:lnT w="0" cap="flat" cmpd="sng" algn="ctr">
-                      <a:noFill/>
+                    <a:lnT w="9525" cap="flat" cmpd="sng" algn="ctr">
+                      <a:solidFill>
+                        <a:srgbClr val="D0D7DE"/>
+                      </a:solidFill>
+                      <a:prstDash val="solid"/>
+                      <a:round/>
+                      <a:headEnd type="none" w="med" len="med"/>
+                      <a:tailEnd type="none" w="med" len="med"/>
                     </a:lnT>
                     <a:lnB w="9525" cap="flat" cmpd="sng" algn="ctr">
                       <a:solidFill>
@@ -2850,7 +2914,7 @@
                     <a:bodyPr/>
                     <a:lstStyle/>
                     <a:p>
-                      <a:pPr indent="0" marL="0">
+                      <a:pPr marL="0" indent="0">
                         <a:buNone/>
                       </a:pPr>
                       <a:r>
@@ -2878,8 +2942,14 @@
                     <a:lnR w="0" cap="flat" cmpd="sng" algn="ctr">
                       <a:noFill/>
                     </a:lnR>
-                    <a:lnT w="0" cap="flat" cmpd="sng" algn="ctr">
-                      <a:noFill/>
+                    <a:lnT w="9525" cap="flat" cmpd="sng" algn="ctr">
+                      <a:solidFill>
+                        <a:srgbClr val="D0D7DE"/>
+                      </a:solidFill>
+                      <a:prstDash val="solid"/>
+                      <a:round/>
+                      <a:headEnd type="none" w="med" len="med"/>
+                      <a:tailEnd type="none" w="med" len="med"/>
                     </a:lnT>
                     <a:lnB w="9525" cap="flat" cmpd="sng" algn="ctr">
                       <a:solidFill>
@@ -2892,6 +2962,11 @@
                     </a:lnB>
                   </a:tcPr>
                 </a:tc>
+                <a:extLst>
+                  <a:ext uri="{0D108BD9-81ED-4DB2-BD59-A6C34878D82A}">
+                    <a16:rowId xmlns:a16="http://schemas.microsoft.com/office/drawing/2014/main" val="10009"/>
+                  </a:ext>
+                </a:extLst>
               </a:tr>
             </a:tbl>
           </a:graphicData>
@@ -2899,14 +2974,14 @@
       </p:graphicFrame>
       <p:pic>
         <p:nvPicPr>
-          <p:cNvPr id="5" name="Logo 관제 웹 JavaScript" descr="JavaScript">    </p:cNvPr>
+          <p:cNvPr id="5" name="Logo 관제 웹 JavaScript" descr="JavaScript"/>
           <p:cNvPicPr>
             <a:picLocks noChangeAspect="1"/>
           </p:cNvPicPr>
           <p:nvPr/>
         </p:nvPicPr>
         <p:blipFill>
-          <a:blip r:embed="rId1"/>
+          <a:blip r:embed="rId3"/>
           <a:stretch>
             <a:fillRect/>
           </a:stretch>
@@ -2923,14 +2998,14 @@
       </p:pic>
       <p:pic>
         <p:nvPicPr>
-          <p:cNvPr id="6" name="Logo 관제 웹 HTML5" descr="HTML5">    </p:cNvPr>
+          <p:cNvPr id="6" name="Logo 관제 웹 HTML5" descr="HTML5"/>
           <p:cNvPicPr>
             <a:picLocks noChangeAspect="1"/>
           </p:cNvPicPr>
           <p:nvPr/>
         </p:nvPicPr>
         <p:blipFill>
-          <a:blip r:embed="rId2"/>
+          <a:blip r:embed="rId4"/>
           <a:stretch>
             <a:fillRect/>
           </a:stretch>
@@ -2947,14 +3022,14 @@
       </p:pic>
       <p:pic>
         <p:nvPicPr>
-          <p:cNvPr id="7" name="Logo 관제 웹 CSS" descr="CSS">    </p:cNvPr>
+          <p:cNvPr id="7" name="Logo 관제 웹 CSS" descr="CSS"/>
           <p:cNvPicPr>
             <a:picLocks noChangeAspect="1"/>
           </p:cNvPicPr>
           <p:nvPr/>
         </p:nvPicPr>
         <p:blipFill>
-          <a:blip r:embed="rId3"/>
+          <a:blip r:embed="rId5"/>
           <a:stretch>
             <a:fillRect/>
           </a:stretch>
@@ -2971,14 +3046,14 @@
       </p:pic>
       <p:pic>
         <p:nvPicPr>
-          <p:cNvPr id="8" name="Logo 관제 웹 Leaflet" descr="Leaflet">    </p:cNvPr>
+          <p:cNvPr id="8" name="Logo 관제 웹 Leaflet" descr="Leaflet"/>
           <p:cNvPicPr>
             <a:picLocks noChangeAspect="1"/>
           </p:cNvPicPr>
           <p:nvPr/>
         </p:nvPicPr>
         <p:blipFill>
-          <a:blip r:embed="rId4"/>
+          <a:blip r:embed="rId6"/>
           <a:stretch>
             <a:fillRect/>
           </a:stretch>
@@ -2995,14 +3070,14 @@
       </p:pic>
       <p:pic>
         <p:nvPicPr>
-          <p:cNvPr id="9" name="Logo 업무 백엔드 TypeScript" descr="TypeScript">    </p:cNvPr>
+          <p:cNvPr id="9" name="Logo 업무 백엔드 TypeScript" descr="TypeScript"/>
           <p:cNvPicPr>
             <a:picLocks noChangeAspect="1"/>
           </p:cNvPicPr>
           <p:nvPr/>
         </p:nvPicPr>
         <p:blipFill>
-          <a:blip r:embed="rId5"/>
+          <a:blip r:embed="rId7"/>
           <a:stretch>
             <a:fillRect/>
           </a:stretch>
@@ -3019,14 +3094,14 @@
       </p:pic>
       <p:pic>
         <p:nvPicPr>
-          <p:cNvPr id="10" name="Logo 업무 백엔드 Express" descr="Express">    </p:cNvPr>
+          <p:cNvPr id="10" name="Logo 업무 백엔드 Express" descr="Express"/>
           <p:cNvPicPr>
             <a:picLocks noChangeAspect="1"/>
           </p:cNvPicPr>
           <p:nvPr/>
         </p:nvPicPr>
         <p:blipFill>
-          <a:blip r:embed="rId6"/>
+          <a:blip r:embed="rId8"/>
           <a:stretch>
             <a:fillRect/>
           </a:stretch>
@@ -3043,14 +3118,14 @@
       </p:pic>
       <p:pic>
         <p:nvPicPr>
-          <p:cNvPr id="11" name="Logo 업무 백엔드 Prisma" descr="Prisma">    </p:cNvPr>
+          <p:cNvPr id="11" name="Logo 업무 백엔드 Prisma" descr="Prisma"/>
           <p:cNvPicPr>
             <a:picLocks noChangeAspect="1"/>
           </p:cNvPicPr>
           <p:nvPr/>
         </p:nvPicPr>
         <p:blipFill>
-          <a:blip r:embed="rId7"/>
+          <a:blip r:embed="rId9"/>
           <a:stretch>
             <a:fillRect/>
           </a:stretch>
@@ -3067,14 +3142,14 @@
       </p:pic>
       <p:pic>
         <p:nvPicPr>
-          <p:cNvPr id="12" name="Logo 경로·추적 Python" descr="Python">    </p:cNvPr>
+          <p:cNvPr id="12" name="Logo 경로·추적 Python" descr="Python"/>
           <p:cNvPicPr>
             <a:picLocks noChangeAspect="1"/>
           </p:cNvPicPr>
           <p:nvPr/>
         </p:nvPicPr>
         <p:blipFill>
-          <a:blip r:embed="rId8"/>
+          <a:blip r:embed="rId10"/>
           <a:stretch>
             <a:fillRect/>
           </a:stretch>
@@ -3091,14 +3166,14 @@
       </p:pic>
       <p:pic>
         <p:nvPicPr>
-          <p:cNvPr id="13" name="Logo 경로·추적 FastAPI" descr="FastAPI">    </p:cNvPr>
+          <p:cNvPr id="13" name="Logo 경로·추적 FastAPI" descr="FastAPI"/>
           <p:cNvPicPr>
             <a:picLocks noChangeAspect="1"/>
           </p:cNvPicPr>
           <p:nvPr/>
         </p:nvPicPr>
         <p:blipFill>
-          <a:blip r:embed="rId9"/>
+          <a:blip r:embed="rId11"/>
           <a:stretch>
             <a:fillRect/>
           </a:stretch>
@@ -3115,14 +3190,14 @@
       </p:pic>
       <p:pic>
         <p:nvPicPr>
-          <p:cNvPr id="14" name="Logo 경로·추적 OpenStreetMap" descr="OpenStreetMap">    </p:cNvPr>
+          <p:cNvPr id="14" name="Logo 경로·추적 OpenStreetMap" descr="OpenStreetMap"/>
           <p:cNvPicPr>
             <a:picLocks noChangeAspect="1"/>
           </p:cNvPicPr>
           <p:nvPr/>
         </p:nvPicPr>
         <p:blipFill>
-          <a:blip r:embed="rId10"/>
+          <a:blip r:embed="rId12"/>
           <a:stretch>
             <a:fillRect/>
           </a:stretch>
@@ -3139,14 +3214,14 @@
       </p:pic>
       <p:pic>
         <p:nvPicPr>
-          <p:cNvPr id="15" name="Logo 미디어 릴레이 Go" descr="Go">    </p:cNvPr>
+          <p:cNvPr id="15" name="Logo 미디어 릴레이 Go" descr="Go"/>
           <p:cNvPicPr>
             <a:picLocks noChangeAspect="1"/>
           </p:cNvPicPr>
           <p:nvPr/>
         </p:nvPicPr>
         <p:blipFill>
-          <a:blip r:embed="rId11"/>
+          <a:blip r:embed="rId13"/>
           <a:stretch>
             <a:fillRect/>
           </a:stretch>
@@ -3163,14 +3238,14 @@
       </p:pic>
       <p:pic>
         <p:nvPicPr>
-          <p:cNvPr id="16" name="Logo 미디어 릴레이 WebRTC" descr="WebRTC">    </p:cNvPr>
+          <p:cNvPr id="16" name="Logo 미디어 릴레이 WebRTC" descr="WebRTC"/>
           <p:cNvPicPr>
             <a:picLocks noChangeAspect="1"/>
           </p:cNvPicPr>
           <p:nvPr/>
         </p:nvPicPr>
         <p:blipFill>
-          <a:blip r:embed="rId12"/>
+          <a:blip r:embed="rId14"/>
           <a:stretch>
             <a:fillRect/>
           </a:stretch>
@@ -3187,14 +3262,14 @@
       </p:pic>
       <p:pic>
         <p:nvPicPr>
-          <p:cNvPr id="17" name="Logo 비전 Python" descr="Python">    </p:cNvPr>
+          <p:cNvPr id="17" name="Logo 비전 Python" descr="Python"/>
           <p:cNvPicPr>
             <a:picLocks noChangeAspect="1"/>
           </p:cNvPicPr>
           <p:nvPr/>
         </p:nvPicPr>
         <p:blipFill>
-          <a:blip r:embed="rId13"/>
+          <a:blip r:embed="rId10"/>
           <a:stretch>
             <a:fillRect/>
           </a:stretch>
@@ -3211,14 +3286,14 @@
       </p:pic>
       <p:pic>
         <p:nvPicPr>
-          <p:cNvPr id="18" name="Logo 비전 PyTorch" descr="PyTorch">    </p:cNvPr>
+          <p:cNvPr id="18" name="Logo 비전 PyTorch" descr="PyTorch"/>
           <p:cNvPicPr>
             <a:picLocks noChangeAspect="1"/>
           </p:cNvPicPr>
           <p:nvPr/>
         </p:nvPicPr>
         <p:blipFill>
-          <a:blip r:embed="rId14"/>
+          <a:blip r:embed="rId15"/>
           <a:stretch>
             <a:fillRect/>
           </a:stretch>
@@ -3235,14 +3310,14 @@
       </p:pic>
       <p:pic>
         <p:nvPicPr>
-          <p:cNvPr id="19" name="Logo 비전 Ultralytics" descr="Ultralytics">    </p:cNvPr>
+          <p:cNvPr id="19" name="Logo 비전 Ultralytics" descr="Ultralytics"/>
           <p:cNvPicPr>
             <a:picLocks noChangeAspect="1"/>
           </p:cNvPicPr>
           <p:nvPr/>
         </p:nvPicPr>
         <p:blipFill>
-          <a:blip r:embed="rId15"/>
+          <a:blip r:embed="rId16"/>
           <a:stretch>
             <a:fillRect/>
           </a:stretch>
@@ -3259,14 +3334,14 @@
       </p:pic>
       <p:pic>
         <p:nvPicPr>
-          <p:cNvPr id="20" name="Logo 비전 NVIDIA" descr="NVIDIA">    </p:cNvPr>
+          <p:cNvPr id="20" name="Logo 비전 NVIDIA" descr="NVIDIA"/>
           <p:cNvPicPr>
             <a:picLocks noChangeAspect="1"/>
           </p:cNvPicPr>
           <p:nvPr/>
         </p:nvPicPr>
         <p:blipFill>
-          <a:blip r:embed="rId16"/>
+          <a:blip r:embed="rId17"/>
           <a:stretch>
             <a:fillRect/>
           </a:stretch>
@@ -3283,14 +3358,14 @@
       </p:pic>
       <p:pic>
         <p:nvPicPr>
-          <p:cNvPr id="21" name="Logo 차량 단말 Kotlin" descr="Kotlin">    </p:cNvPr>
+          <p:cNvPr id="21" name="Logo 차량 단말 Kotlin" descr="Kotlin"/>
           <p:cNvPicPr>
             <a:picLocks noChangeAspect="1"/>
           </p:cNvPicPr>
           <p:nvPr/>
         </p:nvPicPr>
         <p:blipFill>
-          <a:blip r:embed="rId17"/>
+          <a:blip r:embed="rId18"/>
           <a:stretch>
             <a:fillRect/>
           </a:stretch>
@@ -3307,14 +3382,14 @@
       </p:pic>
       <p:pic>
         <p:nvPicPr>
-          <p:cNvPr id="22" name="Logo 차량 단말 Android" descr="Android">    </p:cNvPr>
+          <p:cNvPr id="22" name="Logo 차량 단말 Android" descr="Android"/>
           <p:cNvPicPr>
             <a:picLocks noChangeAspect="1"/>
           </p:cNvPicPr>
           <p:nvPr/>
         </p:nvPicPr>
         <p:blipFill>
-          <a:blip r:embed="rId18"/>
+          <a:blip r:embed="rId19"/>
           <a:stretch>
             <a:fillRect/>
           </a:stretch>
@@ -3331,14 +3406,14 @@
       </p:pic>
       <p:pic>
         <p:nvPicPr>
-          <p:cNvPr id="23" name="Logo 차량 단말 WebRTC" descr="WebRTC">    </p:cNvPr>
+          <p:cNvPr id="23" name="Logo 차량 단말 WebRTC" descr="WebRTC"/>
           <p:cNvPicPr>
             <a:picLocks noChangeAspect="1"/>
           </p:cNvPicPr>
           <p:nvPr/>
         </p:nvPicPr>
         <p:blipFill>
-          <a:blip r:embed="rId19"/>
+          <a:blip r:embed="rId14"/>
           <a:stretch>
             <a:fillRect/>
           </a:stretch>
@@ -3355,7 +3430,7 @@
       </p:pic>
       <p:pic>
         <p:nvPicPr>
-          <p:cNvPr id="24" name="Logo 업무 저장소 PostgreSQL" descr="PostgreSQL">    </p:cNvPr>
+          <p:cNvPr id="24" name="Logo 업무 저장소 PostgreSQL" descr="PostgreSQL"/>
           <p:cNvPicPr>
             <a:picLocks noChangeAspect="1"/>
           </p:cNvPicPr>
@@ -3379,7 +3454,7 @@
       </p:pic>
       <p:pic>
         <p:nvPicPr>
-          <p:cNvPr id="25" name="Logo 객체 저장소 MinIO" descr="MinIO">    </p:cNvPr>
+          <p:cNvPr id="25" name="Logo 객체 저장소 MinIO" descr="MinIO"/>
           <p:cNvPicPr>
             <a:picLocks noChangeAspect="1"/>
           </p:cNvPicPr>
@@ -3393,8 +3468,8 @@
         </p:blipFill>
         <p:spPr>
           <a:xfrm>
-            <a:off x="2423160" y="5536692"/>
-            <a:ext cx="1012811" cy="173736"/>
+            <a:off x="2374900" y="5536691"/>
+            <a:ext cx="436033" cy="141734"/>
           </a:xfrm>
           <a:prstGeom prst="rect">
             <a:avLst/>
@@ -3403,7 +3478,7 @@
       </p:pic>
       <p:pic>
         <p:nvPicPr>
-          <p:cNvPr id="26" name="Logo 인프라 Docker" descr="Docker">    </p:cNvPr>
+          <p:cNvPr id="26" name="Logo 인프라 Docker" descr="Docker"/>
           <p:cNvPicPr>
             <a:picLocks noChangeAspect="1"/>
           </p:cNvPicPr>
@@ -3427,7 +3502,7 @@
       </p:pic>
       <p:pic>
         <p:nvPicPr>
-          <p:cNvPr id="27" name="Logo 인프라 NGINX" descr="NGINX">    </p:cNvPr>
+          <p:cNvPr id="27" name="Logo 인프라 NGINX" descr="NGINX"/>
           <p:cNvPicPr>
             <a:picLocks noChangeAspect="1"/>
           </p:cNvPicPr>
@@ -3451,7 +3526,7 @@
       </p:pic>
       <p:pic>
         <p:nvPicPr>
-          <p:cNvPr id="28" name="Logo 인프라 Coturn (비공식 아이콘)" descr="Coturn (비공식 아이콘)">    </p:cNvPr>
+          <p:cNvPr id="28" name="Logo 인프라 Coturn (비공식 아이콘)" descr="Coturn (비공식 아이콘)"/>
           <p:cNvPicPr>
             <a:picLocks noChangeAspect="1"/>
           </p:cNvPicPr>
@@ -3774,4 +3849,299 @@
     </a:ext>
   </a:extLst>
 </a:theme>
+</file>
+
+<file path=ppt/theme/theme2.xml><?xml version="1.0" encoding="utf-8"?>
+<a:theme xmlns:a="http://schemas.openxmlformats.org/drawingml/2006/main" name="Office 테마">
+  <a:themeElements>
+    <a:clrScheme name="Office">
+      <a:dk1>
+        <a:sysClr val="windowText" lastClr="000000"/>
+      </a:dk1>
+      <a:lt1>
+        <a:sysClr val="window" lastClr="FFFFFF"/>
+      </a:lt1>
+      <a:dk2>
+        <a:srgbClr val="44546A"/>
+      </a:dk2>
+      <a:lt2>
+        <a:srgbClr val="E7E6E6"/>
+      </a:lt2>
+      <a:accent1>
+        <a:srgbClr val="4472C4"/>
+      </a:accent1>
+      <a:accent2>
+        <a:srgbClr val="ED7D31"/>
+      </a:accent2>
+      <a:accent3>
+        <a:srgbClr val="A5A5A5"/>
+      </a:accent3>
+      <a:accent4>
+        <a:srgbClr val="FFC000"/>
+      </a:accent4>
+      <a:accent5>
+        <a:srgbClr val="5B9BD5"/>
+      </a:accent5>
+      <a:accent6>
+        <a:srgbClr val="70AD47"/>
+      </a:accent6>
+      <a:hlink>
+        <a:srgbClr val="0563C1"/>
+      </a:hlink>
+      <a:folHlink>
+        <a:srgbClr val="954F72"/>
+      </a:folHlink>
+    </a:clrScheme>
+    <a:fontScheme name="Office">
+      <a:majorFont>
+        <a:latin typeface="맑은 고딕" panose="020F0302020204030204"/>
+        <a:ea typeface=""/>
+        <a:cs typeface=""/>
+        <a:font script="Jpan" typeface="游ゴシック Light"/>
+        <a:font script="Hang" typeface="맑은 고딕"/>
+        <a:font script="Hans" typeface="等线 Light"/>
+        <a:font script="Hant" typeface="新細明體"/>
+        <a:font script="Arab" typeface="Times New Roman"/>
+        <a:font script="Hebr" typeface="Times New Roman"/>
+        <a:font script="Thai" typeface="Angsana New"/>
+        <a:font script="Ethi" typeface="Nyala"/>
+        <a:font script="Beng" typeface="Vrinda"/>
+        <a:font script="Gujr" typeface="Shruti"/>
+        <a:font script="Khmr" typeface="MoolBoran"/>
+        <a:font script="Knda" typeface="Tunga"/>
+        <a:font script="Guru" typeface="Raavi"/>
+        <a:font script="Cans" typeface="Euphemia"/>
+        <a:font script="Cher" typeface="Plantagenet Cherokee"/>
+        <a:font script="Yiii" typeface="Microsoft Yi Baiti"/>
+        <a:font script="Tibt" typeface="Microsoft Himalaya"/>
+        <a:font script="Thaa" typeface="MV Boli"/>
+        <a:font script="Deva" typeface="Mangal"/>
+        <a:font script="Telu" typeface="Gautami"/>
+        <a:font script="Taml" typeface="Latha"/>
+        <a:font script="Syrc" typeface="Estrangelo Edessa"/>
+        <a:font script="Orya" typeface="Kalinga"/>
+        <a:font script="Mlym" typeface="Kartika"/>
+        <a:font script="Laoo" typeface="DokChampa"/>
+        <a:font script="Sinh" typeface="Iskoola Pota"/>
+        <a:font script="Mong" typeface="Mongolian Baiti"/>
+        <a:font script="Viet" typeface="Times New Roman"/>
+        <a:font script="Uigh" typeface="Microsoft Uighur"/>
+        <a:font script="Geor" typeface="Sylfaen"/>
+        <a:font script="Armn" typeface="Arial"/>
+        <a:font script="Bugi" typeface="Leelawadee UI"/>
+        <a:font script="Bopo" typeface="Microsoft JhengHei"/>
+        <a:font script="Java" typeface="Javanese Text"/>
+        <a:font script="Lisu" typeface="Segoe UI"/>
+        <a:font script="Mymr" typeface="Myanmar Text"/>
+        <a:font script="Nkoo" typeface="Ebrima"/>
+        <a:font script="Olck" typeface="Nirmala UI"/>
+        <a:font script="Osma" typeface="Ebrima"/>
+        <a:font script="Phag" typeface="Phagspa"/>
+        <a:font script="Syrn" typeface="Estrangelo Edessa"/>
+        <a:font script="Syrj" typeface="Estrangelo Edessa"/>
+        <a:font script="Syre" typeface="Estrangelo Edessa"/>
+        <a:font script="Sora" typeface="Nirmala UI"/>
+        <a:font script="Tale" typeface="Microsoft Tai Le"/>
+        <a:font script="Talu" typeface="Microsoft New Tai Lue"/>
+        <a:font script="Tfng" typeface="Ebrima"/>
+      </a:majorFont>
+      <a:minorFont>
+        <a:latin typeface="맑은 고딕" panose="020F0502020204030204"/>
+        <a:ea typeface=""/>
+        <a:cs typeface=""/>
+        <a:font script="Jpan" typeface="游ゴシック"/>
+        <a:font script="Hang" typeface="맑은 고딕"/>
+        <a:font script="Hans" typeface="等线"/>
+        <a:font script="Hant" typeface="新細明體"/>
+        <a:font script="Arab" typeface="Arial"/>
+        <a:font script="Hebr" typeface="Arial"/>
+        <a:font script="Thai" typeface="Cordia New"/>
+        <a:font script="Ethi" typeface="Nyala"/>
+        <a:font script="Beng" typeface="Vrinda"/>
+        <a:font script="Gujr" typeface="Shruti"/>
+        <a:font script="Khmr" typeface="DaunPenh"/>
+        <a:font script="Knda" typeface="Tunga"/>
+        <a:font script="Guru" typeface="Raavi"/>
+        <a:font script="Cans" typeface="Euphemia"/>
+        <a:font script="Cher" typeface="Plantagenet Cherokee"/>
+        <a:font script="Yiii" typeface="Microsoft Yi Baiti"/>
+        <a:font script="Tibt" typeface="Microsoft Himalaya"/>
+        <a:font script="Thaa" typeface="MV Boli"/>
+        <a:font script="Deva" typeface="Mangal"/>
+        <a:font script="Telu" typeface="Gautami"/>
+        <a:font script="Taml" typeface="Latha"/>
+        <a:font script="Syrc" typeface="Estrangelo Edessa"/>
+        <a:font script="Orya" typeface="Kalinga"/>
+        <a:font script="Mlym" typeface="Kartika"/>
+        <a:font script="Laoo" typeface="DokChampa"/>
+        <a:font script="Sinh" typeface="Iskoola Pota"/>
+        <a:font script="Mong" typeface="Mongolian Baiti"/>
+        <a:font script="Viet" typeface="Arial"/>
+        <a:font script="Uigh" typeface="Microsoft Uighur"/>
+        <a:font script="Geor" typeface="Sylfaen"/>
+        <a:font script="Armn" typeface="Arial"/>
+        <a:font script="Bugi" typeface="Leelawadee UI"/>
+        <a:font script="Bopo" typeface="Microsoft JhengHei"/>
+        <a:font script="Java" typeface="Javanese Text"/>
+        <a:font script="Lisu" typeface="Segoe UI"/>
+        <a:font script="Mymr" typeface="Myanmar Text"/>
+        <a:font script="Nkoo" typeface="Ebrima"/>
+        <a:font script="Olck" typeface="Nirmala UI"/>
+        <a:font script="Osma" typeface="Ebrima"/>
+        <a:font script="Phag" typeface="Phagspa"/>
+        <a:font script="Syrn" typeface="Estrangelo Edessa"/>
+        <a:font script="Syrj" typeface="Estrangelo Edessa"/>
+        <a:font script="Syre" typeface="Estrangelo Edessa"/>
+        <a:font script="Sora" typeface="Nirmala UI"/>
+        <a:font script="Tale" typeface="Microsoft Tai Le"/>
+        <a:font script="Talu" typeface="Microsoft New Tai Lue"/>
+        <a:font script="Tfng" typeface="Ebrima"/>
+      </a:minorFont>
+    </a:fontScheme>
+    <a:fmtScheme name="Office">
+      <a:fillStyleLst>
+        <a:solidFill>
+          <a:schemeClr val="phClr"/>
+        </a:solidFill>
+        <a:gradFill rotWithShape="1">
+          <a:gsLst>
+            <a:gs pos="0">
+              <a:schemeClr val="phClr">
+                <a:lumMod val="110000"/>
+                <a:satMod val="105000"/>
+                <a:tint val="67000"/>
+              </a:schemeClr>
+            </a:gs>
+            <a:gs pos="50000">
+              <a:schemeClr val="phClr">
+                <a:lumMod val="105000"/>
+                <a:satMod val="103000"/>
+                <a:tint val="73000"/>
+              </a:schemeClr>
+            </a:gs>
+            <a:gs pos="100000">
+              <a:schemeClr val="phClr">
+                <a:lumMod val="105000"/>
+                <a:satMod val="109000"/>
+                <a:tint val="81000"/>
+              </a:schemeClr>
+            </a:gs>
+          </a:gsLst>
+          <a:lin ang="5400000" scaled="0"/>
+        </a:gradFill>
+        <a:gradFill rotWithShape="1">
+          <a:gsLst>
+            <a:gs pos="0">
+              <a:schemeClr val="phClr">
+                <a:satMod val="103000"/>
+                <a:lumMod val="102000"/>
+                <a:tint val="94000"/>
+              </a:schemeClr>
+            </a:gs>
+            <a:gs pos="50000">
+              <a:schemeClr val="phClr">
+                <a:satMod val="110000"/>
+                <a:lumMod val="100000"/>
+                <a:shade val="100000"/>
+              </a:schemeClr>
+            </a:gs>
+            <a:gs pos="100000">
+              <a:schemeClr val="phClr">
+                <a:lumMod val="99000"/>
+                <a:satMod val="120000"/>
+                <a:shade val="78000"/>
+              </a:schemeClr>
+            </a:gs>
+          </a:gsLst>
+          <a:lin ang="5400000" scaled="0"/>
+        </a:gradFill>
+      </a:fillStyleLst>
+      <a:lnStyleLst>
+        <a:ln w="6350" cap="flat" cmpd="sng" algn="ctr">
+          <a:solidFill>
+            <a:schemeClr val="phClr"/>
+          </a:solidFill>
+          <a:prstDash val="solid"/>
+          <a:miter lim="800000"/>
+        </a:ln>
+        <a:ln w="12700" cap="flat" cmpd="sng" algn="ctr">
+          <a:solidFill>
+            <a:schemeClr val="phClr"/>
+          </a:solidFill>
+          <a:prstDash val="solid"/>
+          <a:miter lim="800000"/>
+        </a:ln>
+        <a:ln w="19050" cap="flat" cmpd="sng" algn="ctr">
+          <a:solidFill>
+            <a:schemeClr val="phClr"/>
+          </a:solidFill>
+          <a:prstDash val="solid"/>
+          <a:miter lim="800000"/>
+        </a:ln>
+      </a:lnStyleLst>
+      <a:effectStyleLst>
+        <a:effectStyle>
+          <a:effectLst/>
+        </a:effectStyle>
+        <a:effectStyle>
+          <a:effectLst/>
+        </a:effectStyle>
+        <a:effectStyle>
+          <a:effectLst>
+            <a:outerShdw blurRad="57150" dist="19050" dir="5400000" algn="ctr" rotWithShape="0">
+              <a:srgbClr val="000000">
+                <a:alpha val="63000"/>
+              </a:srgbClr>
+            </a:outerShdw>
+          </a:effectLst>
+        </a:effectStyle>
+      </a:effectStyleLst>
+      <a:bgFillStyleLst>
+        <a:solidFill>
+          <a:schemeClr val="phClr"/>
+        </a:solidFill>
+        <a:solidFill>
+          <a:schemeClr val="phClr">
+            <a:tint val="95000"/>
+            <a:satMod val="170000"/>
+          </a:schemeClr>
+        </a:solidFill>
+        <a:gradFill rotWithShape="1">
+          <a:gsLst>
+            <a:gs pos="0">
+              <a:schemeClr val="phClr">
+                <a:tint val="93000"/>
+                <a:satMod val="150000"/>
+                <a:shade val="98000"/>
+                <a:lumMod val="102000"/>
+              </a:schemeClr>
+            </a:gs>
+            <a:gs pos="50000">
+              <a:schemeClr val="phClr">
+                <a:tint val="98000"/>
+                <a:satMod val="130000"/>
+                <a:shade val="90000"/>
+                <a:lumMod val="103000"/>
+              </a:schemeClr>
+            </a:gs>
+            <a:gs pos="100000">
+              <a:schemeClr val="phClr">
+                <a:shade val="63000"/>
+                <a:satMod val="120000"/>
+              </a:schemeClr>
+            </a:gs>
+          </a:gsLst>
+          <a:lin ang="5400000" scaled="0"/>
+        </a:gradFill>
+      </a:bgFillStyleLst>
+    </a:fmtScheme>
+  </a:themeElements>
+  <a:objectDefaults/>
+  <a:extraClrSchemeLst/>
+  <a:extLst>
+    <a:ext uri="{05A4C25C-085E-4340-85A3-A5531E510DB2}">
+      <thm15:themeFamily xmlns:thm15="http://schemas.microsoft.com/office/thememl/2012/main" name="Office Theme" id="{62F939B6-93AF-4DB8-9C6B-D6C7DFDC589F}" vid="{4A3C46E8-61CC-4603-A589-7422A47A8E4A}"/>
+    </a:ext>
+  </a:extLst>
+</a:theme>
 </file>
</xml_diff>